<commit_message>
Update samples and README - 2026-05-06 20:13 UTC
</commit_message>
<xml_diff>
--- a/samples/pptx_embedded_bat.pptx
+++ b/samples/pptx_embedded_bat.pptx
@@ -129,7 +129,7 @@
           <p:cNvPr id="2" name="Title 1">
             <a:extLst>
               <a:ext uri="{FF2B5EF4-FFF2-40B4-BE49-F238E27FC236}">
-                <a16:creationId xmlns:a16="http://schemas.microsoft.com/office/drawing/2014/main" id="{C4FE083D-9948-D02F-FF66-85CA4F809BD8}"/>
+                <a16:creationId xmlns:a16="http://schemas.microsoft.com/office/drawing/2014/main" id="{5FB097B0-C774-A72A-0B74-6AED6970409B}"/>
               </a:ext>
             </a:extLst>
           </p:cNvPr>
@@ -166,7 +166,7 @@
           <p:cNvPr id="3" name="Subtitle 2">
             <a:extLst>
               <a:ext uri="{FF2B5EF4-FFF2-40B4-BE49-F238E27FC236}">
-                <a16:creationId xmlns:a16="http://schemas.microsoft.com/office/drawing/2014/main" id="{208538DA-6AA4-6CCB-EFE7-55D9B3B74080}"/>
+                <a16:creationId xmlns:a16="http://schemas.microsoft.com/office/drawing/2014/main" id="{9FB5F4EF-CF54-1E24-1C03-9EEE11635F16}"/>
               </a:ext>
             </a:extLst>
           </p:cNvPr>
@@ -236,7 +236,7 @@
           <p:cNvPr id="4" name="Date Placeholder 3">
             <a:extLst>
               <a:ext uri="{FF2B5EF4-FFF2-40B4-BE49-F238E27FC236}">
-                <a16:creationId xmlns:a16="http://schemas.microsoft.com/office/drawing/2014/main" id="{C5BFBA26-70F0-C48F-1D3B-CCA64E574A2D}"/>
+                <a16:creationId xmlns:a16="http://schemas.microsoft.com/office/drawing/2014/main" id="{510E8394-F1A8-B93D-FBCC-018AC4A2060A}"/>
               </a:ext>
             </a:extLst>
           </p:cNvPr>
@@ -252,9 +252,9 @@
           <a:bodyPr/>
           <a:lstStyle/>
           <a:p>
-            <a:fld id="{2D6838C7-3F3A-4EC8-A7EC-194162205776}" type="datetimeFigureOut">
+            <a:fld id="{CDE1DBC8-711B-4D7E-816B-6E1963EFEA10}" type="datetimeFigureOut">
               <a:rPr lang="en-US" smtClean="0"/>
-              <a:t>1/31/2026</a:t>
+              <a:t>5/6/2026</a:t>
             </a:fld>
             <a:endParaRPr lang="en-US"/>
           </a:p>
@@ -265,7 +265,7 @@
           <p:cNvPr id="5" name="Footer Placeholder 4">
             <a:extLst>
               <a:ext uri="{FF2B5EF4-FFF2-40B4-BE49-F238E27FC236}">
-                <a16:creationId xmlns:a16="http://schemas.microsoft.com/office/drawing/2014/main" id="{D70AC4B6-01F6-AF82-A7AF-C9FF10AB820B}"/>
+                <a16:creationId xmlns:a16="http://schemas.microsoft.com/office/drawing/2014/main" id="{96163F7C-E349-63F7-DBFE-63C88FFFFA79}"/>
               </a:ext>
             </a:extLst>
           </p:cNvPr>
@@ -290,7 +290,7 @@
           <p:cNvPr id="6" name="Slide Number Placeholder 5">
             <a:extLst>
               <a:ext uri="{FF2B5EF4-FFF2-40B4-BE49-F238E27FC236}">
-                <a16:creationId xmlns:a16="http://schemas.microsoft.com/office/drawing/2014/main" id="{C07DEAA5-88B0-99E5-9F3B-674D58A4625C}"/>
+                <a16:creationId xmlns:a16="http://schemas.microsoft.com/office/drawing/2014/main" id="{12167C96-8CBE-14D7-8F6B-3020A9F5AB27}"/>
               </a:ext>
             </a:extLst>
           </p:cNvPr>
@@ -306,7 +306,7 @@
           <a:bodyPr/>
           <a:lstStyle/>
           <a:p>
-            <a:fld id="{BF2B263D-A065-4A16-816C-C56F9378FEDD}" type="slidenum">
+            <a:fld id="{2098F123-10FF-4381-B2A9-4229E307DFC7}" type="slidenum">
               <a:rPr lang="en-US" smtClean="0"/>
               <a:t>‹#›</a:t>
             </a:fld>
@@ -317,7 +317,7 @@
     </p:spTree>
     <p:extLst>
       <p:ext uri="{BB962C8B-B14F-4D97-AF65-F5344CB8AC3E}">
-        <p14:creationId xmlns:p14="http://schemas.microsoft.com/office/powerpoint/2010/main" val="3007567379"/>
+        <p14:creationId xmlns:p14="http://schemas.microsoft.com/office/powerpoint/2010/main" val="3537101158"/>
       </p:ext>
     </p:extLst>
   </p:cSld>
@@ -349,7 +349,7 @@
           <p:cNvPr id="2" name="Title 1">
             <a:extLst>
               <a:ext uri="{FF2B5EF4-FFF2-40B4-BE49-F238E27FC236}">
-                <a16:creationId xmlns:a16="http://schemas.microsoft.com/office/drawing/2014/main" id="{C2DDA372-9520-1728-45FB-A8C44CC89932}"/>
+                <a16:creationId xmlns:a16="http://schemas.microsoft.com/office/drawing/2014/main" id="{E0C31959-248F-160B-133F-842629E565CC}"/>
               </a:ext>
             </a:extLst>
           </p:cNvPr>
@@ -377,7 +377,7 @@
           <p:cNvPr id="3" name="Vertical Text Placeholder 2">
             <a:extLst>
               <a:ext uri="{FF2B5EF4-FFF2-40B4-BE49-F238E27FC236}">
-                <a16:creationId xmlns:a16="http://schemas.microsoft.com/office/drawing/2014/main" id="{F1631D20-EE55-5308-14C6-84FD8949CED5}"/>
+                <a16:creationId xmlns:a16="http://schemas.microsoft.com/office/drawing/2014/main" id="{F7E6D14D-022D-3E78-EB48-D03A530734F5}"/>
               </a:ext>
             </a:extLst>
           </p:cNvPr>
@@ -434,7 +434,7 @@
           <p:cNvPr id="4" name="Date Placeholder 3">
             <a:extLst>
               <a:ext uri="{FF2B5EF4-FFF2-40B4-BE49-F238E27FC236}">
-                <a16:creationId xmlns:a16="http://schemas.microsoft.com/office/drawing/2014/main" id="{1303DE8A-7AF2-1C61-477F-B70F418FCAFA}"/>
+                <a16:creationId xmlns:a16="http://schemas.microsoft.com/office/drawing/2014/main" id="{E5ECB923-01FF-E5B6-A6EA-F9F283F504ED}"/>
               </a:ext>
             </a:extLst>
           </p:cNvPr>
@@ -450,9 +450,9 @@
           <a:bodyPr/>
           <a:lstStyle/>
           <a:p>
-            <a:fld id="{2D6838C7-3F3A-4EC8-A7EC-194162205776}" type="datetimeFigureOut">
+            <a:fld id="{CDE1DBC8-711B-4D7E-816B-6E1963EFEA10}" type="datetimeFigureOut">
               <a:rPr lang="en-US" smtClean="0"/>
-              <a:t>1/31/2026</a:t>
+              <a:t>5/6/2026</a:t>
             </a:fld>
             <a:endParaRPr lang="en-US"/>
           </a:p>
@@ -463,7 +463,7 @@
           <p:cNvPr id="5" name="Footer Placeholder 4">
             <a:extLst>
               <a:ext uri="{FF2B5EF4-FFF2-40B4-BE49-F238E27FC236}">
-                <a16:creationId xmlns:a16="http://schemas.microsoft.com/office/drawing/2014/main" id="{49313C5B-9CAF-3DD8-60B1-82B4AA906DD5}"/>
+                <a16:creationId xmlns:a16="http://schemas.microsoft.com/office/drawing/2014/main" id="{56299537-63BC-15B2-03A8-2BB0F1E076FE}"/>
               </a:ext>
             </a:extLst>
           </p:cNvPr>
@@ -488,7 +488,7 @@
           <p:cNvPr id="6" name="Slide Number Placeholder 5">
             <a:extLst>
               <a:ext uri="{FF2B5EF4-FFF2-40B4-BE49-F238E27FC236}">
-                <a16:creationId xmlns:a16="http://schemas.microsoft.com/office/drawing/2014/main" id="{4BCC8346-FB87-E145-3F5B-D15CD3291540}"/>
+                <a16:creationId xmlns:a16="http://schemas.microsoft.com/office/drawing/2014/main" id="{C56A7033-8E65-3FB8-E249-24F26F9DFB05}"/>
               </a:ext>
             </a:extLst>
           </p:cNvPr>
@@ -504,7 +504,7 @@
           <a:bodyPr/>
           <a:lstStyle/>
           <a:p>
-            <a:fld id="{BF2B263D-A065-4A16-816C-C56F9378FEDD}" type="slidenum">
+            <a:fld id="{2098F123-10FF-4381-B2A9-4229E307DFC7}" type="slidenum">
               <a:rPr lang="en-US" smtClean="0"/>
               <a:t>‹#›</a:t>
             </a:fld>
@@ -515,7 +515,7 @@
     </p:spTree>
     <p:extLst>
       <p:ext uri="{BB962C8B-B14F-4D97-AF65-F5344CB8AC3E}">
-        <p14:creationId xmlns:p14="http://schemas.microsoft.com/office/powerpoint/2010/main" val="912546013"/>
+        <p14:creationId xmlns:p14="http://schemas.microsoft.com/office/powerpoint/2010/main" val="2421708651"/>
       </p:ext>
     </p:extLst>
   </p:cSld>
@@ -547,7 +547,7 @@
           <p:cNvPr id="2" name="Vertical Title 1">
             <a:extLst>
               <a:ext uri="{FF2B5EF4-FFF2-40B4-BE49-F238E27FC236}">
-                <a16:creationId xmlns:a16="http://schemas.microsoft.com/office/drawing/2014/main" id="{53982B91-4E49-D5E0-A2B5-93440916D93B}"/>
+                <a16:creationId xmlns:a16="http://schemas.microsoft.com/office/drawing/2014/main" id="{14C294EF-013F-F170-1FFB-6389D23409FF}"/>
               </a:ext>
             </a:extLst>
           </p:cNvPr>
@@ -580,7 +580,7 @@
           <p:cNvPr id="3" name="Vertical Text Placeholder 2">
             <a:extLst>
               <a:ext uri="{FF2B5EF4-FFF2-40B4-BE49-F238E27FC236}">
-                <a16:creationId xmlns:a16="http://schemas.microsoft.com/office/drawing/2014/main" id="{255EDA7F-DAC5-500F-608A-AACDEB915072}"/>
+                <a16:creationId xmlns:a16="http://schemas.microsoft.com/office/drawing/2014/main" id="{58D45B16-1AED-933E-855A-636F54CF7D49}"/>
               </a:ext>
             </a:extLst>
           </p:cNvPr>
@@ -642,7 +642,7 @@
           <p:cNvPr id="4" name="Date Placeholder 3">
             <a:extLst>
               <a:ext uri="{FF2B5EF4-FFF2-40B4-BE49-F238E27FC236}">
-                <a16:creationId xmlns:a16="http://schemas.microsoft.com/office/drawing/2014/main" id="{0525C02F-A971-A87B-3BBD-54036624F490}"/>
+                <a16:creationId xmlns:a16="http://schemas.microsoft.com/office/drawing/2014/main" id="{B44B4EE9-08A7-29EA-4774-DDD087FB79C0}"/>
               </a:ext>
             </a:extLst>
           </p:cNvPr>
@@ -658,9 +658,9 @@
           <a:bodyPr/>
           <a:lstStyle/>
           <a:p>
-            <a:fld id="{2D6838C7-3F3A-4EC8-A7EC-194162205776}" type="datetimeFigureOut">
+            <a:fld id="{CDE1DBC8-711B-4D7E-816B-6E1963EFEA10}" type="datetimeFigureOut">
               <a:rPr lang="en-US" smtClean="0"/>
-              <a:t>1/31/2026</a:t>
+              <a:t>5/6/2026</a:t>
             </a:fld>
             <a:endParaRPr lang="en-US"/>
           </a:p>
@@ -671,7 +671,7 @@
           <p:cNvPr id="5" name="Footer Placeholder 4">
             <a:extLst>
               <a:ext uri="{FF2B5EF4-FFF2-40B4-BE49-F238E27FC236}">
-                <a16:creationId xmlns:a16="http://schemas.microsoft.com/office/drawing/2014/main" id="{FC5904F6-E7CA-7517-8C92-0C098633321C}"/>
+                <a16:creationId xmlns:a16="http://schemas.microsoft.com/office/drawing/2014/main" id="{7DF3B117-AFF8-04FD-902F-5D0D180FF73A}"/>
               </a:ext>
             </a:extLst>
           </p:cNvPr>
@@ -696,7 +696,7 @@
           <p:cNvPr id="6" name="Slide Number Placeholder 5">
             <a:extLst>
               <a:ext uri="{FF2B5EF4-FFF2-40B4-BE49-F238E27FC236}">
-                <a16:creationId xmlns:a16="http://schemas.microsoft.com/office/drawing/2014/main" id="{17FB380A-0B47-C169-FCAD-31F3C8E9D314}"/>
+                <a16:creationId xmlns:a16="http://schemas.microsoft.com/office/drawing/2014/main" id="{1BD042A5-7CB6-8163-9820-2A0E82F95A0C}"/>
               </a:ext>
             </a:extLst>
           </p:cNvPr>
@@ -712,7 +712,7 @@
           <a:bodyPr/>
           <a:lstStyle/>
           <a:p>
-            <a:fld id="{BF2B263D-A065-4A16-816C-C56F9378FEDD}" type="slidenum">
+            <a:fld id="{2098F123-10FF-4381-B2A9-4229E307DFC7}" type="slidenum">
               <a:rPr lang="en-US" smtClean="0"/>
               <a:t>‹#›</a:t>
             </a:fld>
@@ -723,7 +723,7 @@
     </p:spTree>
     <p:extLst>
       <p:ext uri="{BB962C8B-B14F-4D97-AF65-F5344CB8AC3E}">
-        <p14:creationId xmlns:p14="http://schemas.microsoft.com/office/powerpoint/2010/main" val="3190169804"/>
+        <p14:creationId xmlns:p14="http://schemas.microsoft.com/office/powerpoint/2010/main" val="3500885383"/>
       </p:ext>
     </p:extLst>
   </p:cSld>
@@ -755,7 +755,7 @@
           <p:cNvPr id="2" name="Title 1">
             <a:extLst>
               <a:ext uri="{FF2B5EF4-FFF2-40B4-BE49-F238E27FC236}">
-                <a16:creationId xmlns:a16="http://schemas.microsoft.com/office/drawing/2014/main" id="{191D9868-C2D0-2BE5-0080-4FA925A83149}"/>
+                <a16:creationId xmlns:a16="http://schemas.microsoft.com/office/drawing/2014/main" id="{54AC7F04-782D-2DC4-02DE-001C75828DCE}"/>
               </a:ext>
             </a:extLst>
           </p:cNvPr>
@@ -783,7 +783,7 @@
           <p:cNvPr id="3" name="Content Placeholder 2">
             <a:extLst>
               <a:ext uri="{FF2B5EF4-FFF2-40B4-BE49-F238E27FC236}">
-                <a16:creationId xmlns:a16="http://schemas.microsoft.com/office/drawing/2014/main" id="{1E557E2E-5135-2ADE-0B42-17A9F5FEAB5B}"/>
+                <a16:creationId xmlns:a16="http://schemas.microsoft.com/office/drawing/2014/main" id="{92653DB5-8DEA-BA96-8A4C-298060A491F7}"/>
               </a:ext>
             </a:extLst>
           </p:cNvPr>
@@ -840,7 +840,7 @@
           <p:cNvPr id="4" name="Date Placeholder 3">
             <a:extLst>
               <a:ext uri="{FF2B5EF4-FFF2-40B4-BE49-F238E27FC236}">
-                <a16:creationId xmlns:a16="http://schemas.microsoft.com/office/drawing/2014/main" id="{E3DD955B-8A8C-CFB5-C302-ACEF38401559}"/>
+                <a16:creationId xmlns:a16="http://schemas.microsoft.com/office/drawing/2014/main" id="{415B212A-7761-2436-D6C6-FBE241F36779}"/>
               </a:ext>
             </a:extLst>
           </p:cNvPr>
@@ -856,9 +856,9 @@
           <a:bodyPr/>
           <a:lstStyle/>
           <a:p>
-            <a:fld id="{2D6838C7-3F3A-4EC8-A7EC-194162205776}" type="datetimeFigureOut">
+            <a:fld id="{CDE1DBC8-711B-4D7E-816B-6E1963EFEA10}" type="datetimeFigureOut">
               <a:rPr lang="en-US" smtClean="0"/>
-              <a:t>1/31/2026</a:t>
+              <a:t>5/6/2026</a:t>
             </a:fld>
             <a:endParaRPr lang="en-US"/>
           </a:p>
@@ -869,7 +869,7 @@
           <p:cNvPr id="5" name="Footer Placeholder 4">
             <a:extLst>
               <a:ext uri="{FF2B5EF4-FFF2-40B4-BE49-F238E27FC236}">
-                <a16:creationId xmlns:a16="http://schemas.microsoft.com/office/drawing/2014/main" id="{1F68494B-959E-17D3-8EA9-B12407867012}"/>
+                <a16:creationId xmlns:a16="http://schemas.microsoft.com/office/drawing/2014/main" id="{F85D3F36-113C-EA55-AD95-601B173702F3}"/>
               </a:ext>
             </a:extLst>
           </p:cNvPr>
@@ -894,7 +894,7 @@
           <p:cNvPr id="6" name="Slide Number Placeholder 5">
             <a:extLst>
               <a:ext uri="{FF2B5EF4-FFF2-40B4-BE49-F238E27FC236}">
-                <a16:creationId xmlns:a16="http://schemas.microsoft.com/office/drawing/2014/main" id="{9D12647C-A1B4-FA83-72EF-27B50956C0B2}"/>
+                <a16:creationId xmlns:a16="http://schemas.microsoft.com/office/drawing/2014/main" id="{20923392-6B71-089F-9F6E-281A4AF30096}"/>
               </a:ext>
             </a:extLst>
           </p:cNvPr>
@@ -910,7 +910,7 @@
           <a:bodyPr/>
           <a:lstStyle/>
           <a:p>
-            <a:fld id="{BF2B263D-A065-4A16-816C-C56F9378FEDD}" type="slidenum">
+            <a:fld id="{2098F123-10FF-4381-B2A9-4229E307DFC7}" type="slidenum">
               <a:rPr lang="en-US" smtClean="0"/>
               <a:t>‹#›</a:t>
             </a:fld>
@@ -921,7 +921,7 @@
     </p:spTree>
     <p:extLst>
       <p:ext uri="{BB962C8B-B14F-4D97-AF65-F5344CB8AC3E}">
-        <p14:creationId xmlns:p14="http://schemas.microsoft.com/office/powerpoint/2010/main" val="535195734"/>
+        <p14:creationId xmlns:p14="http://schemas.microsoft.com/office/powerpoint/2010/main" val="1038363221"/>
       </p:ext>
     </p:extLst>
   </p:cSld>
@@ -953,7 +953,7 @@
           <p:cNvPr id="2" name="Title 1">
             <a:extLst>
               <a:ext uri="{FF2B5EF4-FFF2-40B4-BE49-F238E27FC236}">
-                <a16:creationId xmlns:a16="http://schemas.microsoft.com/office/drawing/2014/main" id="{45ED2BD6-40B1-6E55-86F1-0FDD133C9FDF}"/>
+                <a16:creationId xmlns:a16="http://schemas.microsoft.com/office/drawing/2014/main" id="{2E358849-2A90-098F-14E1-0E76B5E916A9}"/>
               </a:ext>
             </a:extLst>
           </p:cNvPr>
@@ -990,7 +990,7 @@
           <p:cNvPr id="3" name="Text Placeholder 2">
             <a:extLst>
               <a:ext uri="{FF2B5EF4-FFF2-40B4-BE49-F238E27FC236}">
-                <a16:creationId xmlns:a16="http://schemas.microsoft.com/office/drawing/2014/main" id="{D65BDD3C-64EA-4756-F2E2-11293750A717}"/>
+                <a16:creationId xmlns:a16="http://schemas.microsoft.com/office/drawing/2014/main" id="{9FEBE48D-07E4-1045-9440-7A0E649F510D}"/>
               </a:ext>
             </a:extLst>
           </p:cNvPr>
@@ -1115,7 +1115,7 @@
           <p:cNvPr id="4" name="Date Placeholder 3">
             <a:extLst>
               <a:ext uri="{FF2B5EF4-FFF2-40B4-BE49-F238E27FC236}">
-                <a16:creationId xmlns:a16="http://schemas.microsoft.com/office/drawing/2014/main" id="{ED6F11C9-1F01-3499-ABC2-6E3A1E1311DB}"/>
+                <a16:creationId xmlns:a16="http://schemas.microsoft.com/office/drawing/2014/main" id="{1A07C54B-C6F2-7ABE-494A-129AABDDE7D0}"/>
               </a:ext>
             </a:extLst>
           </p:cNvPr>
@@ -1131,9 +1131,9 @@
           <a:bodyPr/>
           <a:lstStyle/>
           <a:p>
-            <a:fld id="{2D6838C7-3F3A-4EC8-A7EC-194162205776}" type="datetimeFigureOut">
+            <a:fld id="{CDE1DBC8-711B-4D7E-816B-6E1963EFEA10}" type="datetimeFigureOut">
               <a:rPr lang="en-US" smtClean="0"/>
-              <a:t>1/31/2026</a:t>
+              <a:t>5/6/2026</a:t>
             </a:fld>
             <a:endParaRPr lang="en-US"/>
           </a:p>
@@ -1144,7 +1144,7 @@
           <p:cNvPr id="5" name="Footer Placeholder 4">
             <a:extLst>
               <a:ext uri="{FF2B5EF4-FFF2-40B4-BE49-F238E27FC236}">
-                <a16:creationId xmlns:a16="http://schemas.microsoft.com/office/drawing/2014/main" id="{7D20BD1D-34E1-2F00-C5BA-075A4F3E6B25}"/>
+                <a16:creationId xmlns:a16="http://schemas.microsoft.com/office/drawing/2014/main" id="{496C478C-CE67-3441-7094-D206E94810EC}"/>
               </a:ext>
             </a:extLst>
           </p:cNvPr>
@@ -1169,7 +1169,7 @@
           <p:cNvPr id="6" name="Slide Number Placeholder 5">
             <a:extLst>
               <a:ext uri="{FF2B5EF4-FFF2-40B4-BE49-F238E27FC236}">
-                <a16:creationId xmlns:a16="http://schemas.microsoft.com/office/drawing/2014/main" id="{F4B31552-881A-AB23-9132-E4D8E5C56DDC}"/>
+                <a16:creationId xmlns:a16="http://schemas.microsoft.com/office/drawing/2014/main" id="{B7447A2F-9FC7-18E5-C84A-3063F389AC74}"/>
               </a:ext>
             </a:extLst>
           </p:cNvPr>
@@ -1185,7 +1185,7 @@
           <a:bodyPr/>
           <a:lstStyle/>
           <a:p>
-            <a:fld id="{BF2B263D-A065-4A16-816C-C56F9378FEDD}" type="slidenum">
+            <a:fld id="{2098F123-10FF-4381-B2A9-4229E307DFC7}" type="slidenum">
               <a:rPr lang="en-US" smtClean="0"/>
               <a:t>‹#›</a:t>
             </a:fld>
@@ -1196,7 +1196,7 @@
     </p:spTree>
     <p:extLst>
       <p:ext uri="{BB962C8B-B14F-4D97-AF65-F5344CB8AC3E}">
-        <p14:creationId xmlns:p14="http://schemas.microsoft.com/office/powerpoint/2010/main" val="713272698"/>
+        <p14:creationId xmlns:p14="http://schemas.microsoft.com/office/powerpoint/2010/main" val="3741346164"/>
       </p:ext>
     </p:extLst>
   </p:cSld>
@@ -1228,7 +1228,7 @@
           <p:cNvPr id="2" name="Title 1">
             <a:extLst>
               <a:ext uri="{FF2B5EF4-FFF2-40B4-BE49-F238E27FC236}">
-                <a16:creationId xmlns:a16="http://schemas.microsoft.com/office/drawing/2014/main" id="{56146407-80D1-3B8D-4769-98D410BE212B}"/>
+                <a16:creationId xmlns:a16="http://schemas.microsoft.com/office/drawing/2014/main" id="{6C7D479F-0076-1A15-1B61-57B0A8DD8E63}"/>
               </a:ext>
             </a:extLst>
           </p:cNvPr>
@@ -1256,7 +1256,7 @@
           <p:cNvPr id="3" name="Content Placeholder 2">
             <a:extLst>
               <a:ext uri="{FF2B5EF4-FFF2-40B4-BE49-F238E27FC236}">
-                <a16:creationId xmlns:a16="http://schemas.microsoft.com/office/drawing/2014/main" id="{AA45F7F7-BB7C-18AB-0263-9967D7ECB252}"/>
+                <a16:creationId xmlns:a16="http://schemas.microsoft.com/office/drawing/2014/main" id="{A6B56F65-EBAC-014E-6243-9F1D60E3E0F9}"/>
               </a:ext>
             </a:extLst>
           </p:cNvPr>
@@ -1318,7 +1318,7 @@
           <p:cNvPr id="4" name="Content Placeholder 3">
             <a:extLst>
               <a:ext uri="{FF2B5EF4-FFF2-40B4-BE49-F238E27FC236}">
-                <a16:creationId xmlns:a16="http://schemas.microsoft.com/office/drawing/2014/main" id="{907AF2B8-812C-A3BA-78FA-D70180A9FE90}"/>
+                <a16:creationId xmlns:a16="http://schemas.microsoft.com/office/drawing/2014/main" id="{9CEDF937-376A-68E5-082B-7A59B2116EBB}"/>
               </a:ext>
             </a:extLst>
           </p:cNvPr>
@@ -1380,7 +1380,7 @@
           <p:cNvPr id="5" name="Date Placeholder 4">
             <a:extLst>
               <a:ext uri="{FF2B5EF4-FFF2-40B4-BE49-F238E27FC236}">
-                <a16:creationId xmlns:a16="http://schemas.microsoft.com/office/drawing/2014/main" id="{2B0199C5-8FD0-EDDF-F0D0-E9D8FDB9FFD3}"/>
+                <a16:creationId xmlns:a16="http://schemas.microsoft.com/office/drawing/2014/main" id="{B3329157-E8C2-3401-00A3-39917A08FDA1}"/>
               </a:ext>
             </a:extLst>
           </p:cNvPr>
@@ -1396,9 +1396,9 @@
           <a:bodyPr/>
           <a:lstStyle/>
           <a:p>
-            <a:fld id="{2D6838C7-3F3A-4EC8-A7EC-194162205776}" type="datetimeFigureOut">
+            <a:fld id="{CDE1DBC8-711B-4D7E-816B-6E1963EFEA10}" type="datetimeFigureOut">
               <a:rPr lang="en-US" smtClean="0"/>
-              <a:t>1/31/2026</a:t>
+              <a:t>5/6/2026</a:t>
             </a:fld>
             <a:endParaRPr lang="en-US"/>
           </a:p>
@@ -1409,7 +1409,7 @@
           <p:cNvPr id="6" name="Footer Placeholder 5">
             <a:extLst>
               <a:ext uri="{FF2B5EF4-FFF2-40B4-BE49-F238E27FC236}">
-                <a16:creationId xmlns:a16="http://schemas.microsoft.com/office/drawing/2014/main" id="{0233AC1F-30A0-4266-F700-398C0228D6BF}"/>
+                <a16:creationId xmlns:a16="http://schemas.microsoft.com/office/drawing/2014/main" id="{1362711B-5DF7-B899-A3AD-6DF18F691A21}"/>
               </a:ext>
             </a:extLst>
           </p:cNvPr>
@@ -1434,7 +1434,7 @@
           <p:cNvPr id="7" name="Slide Number Placeholder 6">
             <a:extLst>
               <a:ext uri="{FF2B5EF4-FFF2-40B4-BE49-F238E27FC236}">
-                <a16:creationId xmlns:a16="http://schemas.microsoft.com/office/drawing/2014/main" id="{626BBB30-FBFB-192F-E2E9-1A69E5EE346C}"/>
+                <a16:creationId xmlns:a16="http://schemas.microsoft.com/office/drawing/2014/main" id="{889C0909-DC1F-7C9C-D272-F5374AC8774C}"/>
               </a:ext>
             </a:extLst>
           </p:cNvPr>
@@ -1450,7 +1450,7 @@
           <a:bodyPr/>
           <a:lstStyle/>
           <a:p>
-            <a:fld id="{BF2B263D-A065-4A16-816C-C56F9378FEDD}" type="slidenum">
+            <a:fld id="{2098F123-10FF-4381-B2A9-4229E307DFC7}" type="slidenum">
               <a:rPr lang="en-US" smtClean="0"/>
               <a:t>‹#›</a:t>
             </a:fld>
@@ -1461,7 +1461,7 @@
     </p:spTree>
     <p:extLst>
       <p:ext uri="{BB962C8B-B14F-4D97-AF65-F5344CB8AC3E}">
-        <p14:creationId xmlns:p14="http://schemas.microsoft.com/office/powerpoint/2010/main" val="4098973682"/>
+        <p14:creationId xmlns:p14="http://schemas.microsoft.com/office/powerpoint/2010/main" val="4000992804"/>
       </p:ext>
     </p:extLst>
   </p:cSld>
@@ -1493,7 +1493,7 @@
           <p:cNvPr id="2" name="Title 1">
             <a:extLst>
               <a:ext uri="{FF2B5EF4-FFF2-40B4-BE49-F238E27FC236}">
-                <a16:creationId xmlns:a16="http://schemas.microsoft.com/office/drawing/2014/main" id="{3D273C77-5715-DD64-AD75-9CB9E4D4175F}"/>
+                <a16:creationId xmlns:a16="http://schemas.microsoft.com/office/drawing/2014/main" id="{943F8E25-D343-5463-2C73-2D79139DD0A2}"/>
               </a:ext>
             </a:extLst>
           </p:cNvPr>
@@ -1526,7 +1526,7 @@
           <p:cNvPr id="3" name="Text Placeholder 2">
             <a:extLst>
               <a:ext uri="{FF2B5EF4-FFF2-40B4-BE49-F238E27FC236}">
-                <a16:creationId xmlns:a16="http://schemas.microsoft.com/office/drawing/2014/main" id="{10E40E84-76A2-7BD5-3803-9BA960640ACC}"/>
+                <a16:creationId xmlns:a16="http://schemas.microsoft.com/office/drawing/2014/main" id="{119D070F-AC7D-A307-9BA7-C0E537DB0390}"/>
               </a:ext>
             </a:extLst>
           </p:cNvPr>
@@ -1597,7 +1597,7 @@
           <p:cNvPr id="4" name="Content Placeholder 3">
             <a:extLst>
               <a:ext uri="{FF2B5EF4-FFF2-40B4-BE49-F238E27FC236}">
-                <a16:creationId xmlns:a16="http://schemas.microsoft.com/office/drawing/2014/main" id="{79A49BAC-C712-2B0A-039E-621526D8775A}"/>
+                <a16:creationId xmlns:a16="http://schemas.microsoft.com/office/drawing/2014/main" id="{FFD3C363-BA3D-EF52-83CA-CE24452285D6}"/>
               </a:ext>
             </a:extLst>
           </p:cNvPr>
@@ -1659,7 +1659,7 @@
           <p:cNvPr id="5" name="Text Placeholder 4">
             <a:extLst>
               <a:ext uri="{FF2B5EF4-FFF2-40B4-BE49-F238E27FC236}">
-                <a16:creationId xmlns:a16="http://schemas.microsoft.com/office/drawing/2014/main" id="{60D3570D-75AC-F4F9-3386-5670EF44748D}"/>
+                <a16:creationId xmlns:a16="http://schemas.microsoft.com/office/drawing/2014/main" id="{F6B74B6D-56A4-99EB-4F16-8056CE010ADE}"/>
               </a:ext>
             </a:extLst>
           </p:cNvPr>
@@ -1730,7 +1730,7 @@
           <p:cNvPr id="6" name="Content Placeholder 5">
             <a:extLst>
               <a:ext uri="{FF2B5EF4-FFF2-40B4-BE49-F238E27FC236}">
-                <a16:creationId xmlns:a16="http://schemas.microsoft.com/office/drawing/2014/main" id="{6E71B46C-DD0C-3B32-9F15-C202044A378A}"/>
+                <a16:creationId xmlns:a16="http://schemas.microsoft.com/office/drawing/2014/main" id="{5F6B5AD6-81EB-A30C-5537-43053A989FAB}"/>
               </a:ext>
             </a:extLst>
           </p:cNvPr>
@@ -1792,7 +1792,7 @@
           <p:cNvPr id="7" name="Date Placeholder 6">
             <a:extLst>
               <a:ext uri="{FF2B5EF4-FFF2-40B4-BE49-F238E27FC236}">
-                <a16:creationId xmlns:a16="http://schemas.microsoft.com/office/drawing/2014/main" id="{533B3E54-B31F-E736-B48F-AC703C001335}"/>
+                <a16:creationId xmlns:a16="http://schemas.microsoft.com/office/drawing/2014/main" id="{FCA92201-A627-F622-459B-CCD8D98DDB88}"/>
               </a:ext>
             </a:extLst>
           </p:cNvPr>
@@ -1808,9 +1808,9 @@
           <a:bodyPr/>
           <a:lstStyle/>
           <a:p>
-            <a:fld id="{2D6838C7-3F3A-4EC8-A7EC-194162205776}" type="datetimeFigureOut">
+            <a:fld id="{CDE1DBC8-711B-4D7E-816B-6E1963EFEA10}" type="datetimeFigureOut">
               <a:rPr lang="en-US" smtClean="0"/>
-              <a:t>1/31/2026</a:t>
+              <a:t>5/6/2026</a:t>
             </a:fld>
             <a:endParaRPr lang="en-US"/>
           </a:p>
@@ -1821,7 +1821,7 @@
           <p:cNvPr id="8" name="Footer Placeholder 7">
             <a:extLst>
               <a:ext uri="{FF2B5EF4-FFF2-40B4-BE49-F238E27FC236}">
-                <a16:creationId xmlns:a16="http://schemas.microsoft.com/office/drawing/2014/main" id="{BC424817-4B5F-E5A1-84D8-FBF2996BAF28}"/>
+                <a16:creationId xmlns:a16="http://schemas.microsoft.com/office/drawing/2014/main" id="{52E4BEB4-5FDF-81EE-E6EF-50827B57D065}"/>
               </a:ext>
             </a:extLst>
           </p:cNvPr>
@@ -1846,7 +1846,7 @@
           <p:cNvPr id="9" name="Slide Number Placeholder 8">
             <a:extLst>
               <a:ext uri="{FF2B5EF4-FFF2-40B4-BE49-F238E27FC236}">
-                <a16:creationId xmlns:a16="http://schemas.microsoft.com/office/drawing/2014/main" id="{B99E8AD0-B9D0-EEF2-65A2-AC5401606624}"/>
+                <a16:creationId xmlns:a16="http://schemas.microsoft.com/office/drawing/2014/main" id="{4C59A272-2F28-B6BE-BC70-7128D7FB8963}"/>
               </a:ext>
             </a:extLst>
           </p:cNvPr>
@@ -1862,7 +1862,7 @@
           <a:bodyPr/>
           <a:lstStyle/>
           <a:p>
-            <a:fld id="{BF2B263D-A065-4A16-816C-C56F9378FEDD}" type="slidenum">
+            <a:fld id="{2098F123-10FF-4381-B2A9-4229E307DFC7}" type="slidenum">
               <a:rPr lang="en-US" smtClean="0"/>
               <a:t>‹#›</a:t>
             </a:fld>
@@ -1873,7 +1873,7 @@
     </p:spTree>
     <p:extLst>
       <p:ext uri="{BB962C8B-B14F-4D97-AF65-F5344CB8AC3E}">
-        <p14:creationId xmlns:p14="http://schemas.microsoft.com/office/powerpoint/2010/main" val="1701511023"/>
+        <p14:creationId xmlns:p14="http://schemas.microsoft.com/office/powerpoint/2010/main" val="3412846155"/>
       </p:ext>
     </p:extLst>
   </p:cSld>
@@ -1905,7 +1905,7 @@
           <p:cNvPr id="2" name="Title 1">
             <a:extLst>
               <a:ext uri="{FF2B5EF4-FFF2-40B4-BE49-F238E27FC236}">
-                <a16:creationId xmlns:a16="http://schemas.microsoft.com/office/drawing/2014/main" id="{DABE5CCB-9F90-F81F-9B6D-6EF248338FA6}"/>
+                <a16:creationId xmlns:a16="http://schemas.microsoft.com/office/drawing/2014/main" id="{D34FF40F-DB35-4D1B-5C8F-B8B6ECBBAB4C}"/>
               </a:ext>
             </a:extLst>
           </p:cNvPr>
@@ -1933,7 +1933,7 @@
           <p:cNvPr id="3" name="Date Placeholder 2">
             <a:extLst>
               <a:ext uri="{FF2B5EF4-FFF2-40B4-BE49-F238E27FC236}">
-                <a16:creationId xmlns:a16="http://schemas.microsoft.com/office/drawing/2014/main" id="{31C29587-D6C7-8528-A0E0-09B519CC893D}"/>
+                <a16:creationId xmlns:a16="http://schemas.microsoft.com/office/drawing/2014/main" id="{933512F8-1758-D7B3-41F6-538694FEF824}"/>
               </a:ext>
             </a:extLst>
           </p:cNvPr>
@@ -1949,9 +1949,9 @@
           <a:bodyPr/>
           <a:lstStyle/>
           <a:p>
-            <a:fld id="{2D6838C7-3F3A-4EC8-A7EC-194162205776}" type="datetimeFigureOut">
+            <a:fld id="{CDE1DBC8-711B-4D7E-816B-6E1963EFEA10}" type="datetimeFigureOut">
               <a:rPr lang="en-US" smtClean="0"/>
-              <a:t>1/31/2026</a:t>
+              <a:t>5/6/2026</a:t>
             </a:fld>
             <a:endParaRPr lang="en-US"/>
           </a:p>
@@ -1962,7 +1962,7 @@
           <p:cNvPr id="4" name="Footer Placeholder 3">
             <a:extLst>
               <a:ext uri="{FF2B5EF4-FFF2-40B4-BE49-F238E27FC236}">
-                <a16:creationId xmlns:a16="http://schemas.microsoft.com/office/drawing/2014/main" id="{B0F6C120-5CBF-28C6-BF09-D50E18B5F16B}"/>
+                <a16:creationId xmlns:a16="http://schemas.microsoft.com/office/drawing/2014/main" id="{B45C1E37-0D3C-8320-598F-539AD8D4DB14}"/>
               </a:ext>
             </a:extLst>
           </p:cNvPr>
@@ -1987,7 +1987,7 @@
           <p:cNvPr id="5" name="Slide Number Placeholder 4">
             <a:extLst>
               <a:ext uri="{FF2B5EF4-FFF2-40B4-BE49-F238E27FC236}">
-                <a16:creationId xmlns:a16="http://schemas.microsoft.com/office/drawing/2014/main" id="{3D7A2105-1543-229A-2180-DB9F808D6F8E}"/>
+                <a16:creationId xmlns:a16="http://schemas.microsoft.com/office/drawing/2014/main" id="{E2E0FAB2-4A23-6EA8-5113-464C88036C0F}"/>
               </a:ext>
             </a:extLst>
           </p:cNvPr>
@@ -2003,7 +2003,7 @@
           <a:bodyPr/>
           <a:lstStyle/>
           <a:p>
-            <a:fld id="{BF2B263D-A065-4A16-816C-C56F9378FEDD}" type="slidenum">
+            <a:fld id="{2098F123-10FF-4381-B2A9-4229E307DFC7}" type="slidenum">
               <a:rPr lang="en-US" smtClean="0"/>
               <a:t>‹#›</a:t>
             </a:fld>
@@ -2014,7 +2014,7 @@
     </p:spTree>
     <p:extLst>
       <p:ext uri="{BB962C8B-B14F-4D97-AF65-F5344CB8AC3E}">
-        <p14:creationId xmlns:p14="http://schemas.microsoft.com/office/powerpoint/2010/main" val="2248503359"/>
+        <p14:creationId xmlns:p14="http://schemas.microsoft.com/office/powerpoint/2010/main" val="3300053734"/>
       </p:ext>
     </p:extLst>
   </p:cSld>
@@ -2046,7 +2046,7 @@
           <p:cNvPr id="2" name="Date Placeholder 1">
             <a:extLst>
               <a:ext uri="{FF2B5EF4-FFF2-40B4-BE49-F238E27FC236}">
-                <a16:creationId xmlns:a16="http://schemas.microsoft.com/office/drawing/2014/main" id="{3FE1C73C-ECA6-30FD-F2CC-C8A39BEC15A6}"/>
+                <a16:creationId xmlns:a16="http://schemas.microsoft.com/office/drawing/2014/main" id="{4E6843A7-3704-C183-93FA-105BE379C5E5}"/>
               </a:ext>
             </a:extLst>
           </p:cNvPr>
@@ -2062,9 +2062,9 @@
           <a:bodyPr/>
           <a:lstStyle/>
           <a:p>
-            <a:fld id="{2D6838C7-3F3A-4EC8-A7EC-194162205776}" type="datetimeFigureOut">
+            <a:fld id="{CDE1DBC8-711B-4D7E-816B-6E1963EFEA10}" type="datetimeFigureOut">
               <a:rPr lang="en-US" smtClean="0"/>
-              <a:t>1/31/2026</a:t>
+              <a:t>5/6/2026</a:t>
             </a:fld>
             <a:endParaRPr lang="en-US"/>
           </a:p>
@@ -2075,7 +2075,7 @@
           <p:cNvPr id="3" name="Footer Placeholder 2">
             <a:extLst>
               <a:ext uri="{FF2B5EF4-FFF2-40B4-BE49-F238E27FC236}">
-                <a16:creationId xmlns:a16="http://schemas.microsoft.com/office/drawing/2014/main" id="{5D35F8D7-FB38-CF5D-4A01-4C55278A2313}"/>
+                <a16:creationId xmlns:a16="http://schemas.microsoft.com/office/drawing/2014/main" id="{6C261032-B7C3-B816-C0F6-5674F0A5E515}"/>
               </a:ext>
             </a:extLst>
           </p:cNvPr>
@@ -2100,7 +2100,7 @@
           <p:cNvPr id="4" name="Slide Number Placeholder 3">
             <a:extLst>
               <a:ext uri="{FF2B5EF4-FFF2-40B4-BE49-F238E27FC236}">
-                <a16:creationId xmlns:a16="http://schemas.microsoft.com/office/drawing/2014/main" id="{40A8DAE6-5252-06DF-218C-6613BCF06342}"/>
+                <a16:creationId xmlns:a16="http://schemas.microsoft.com/office/drawing/2014/main" id="{A1B79A3C-9B34-59F8-5A8B-8F3D17CC8889}"/>
               </a:ext>
             </a:extLst>
           </p:cNvPr>
@@ -2116,7 +2116,7 @@
           <a:bodyPr/>
           <a:lstStyle/>
           <a:p>
-            <a:fld id="{BF2B263D-A065-4A16-816C-C56F9378FEDD}" type="slidenum">
+            <a:fld id="{2098F123-10FF-4381-B2A9-4229E307DFC7}" type="slidenum">
               <a:rPr lang="en-US" smtClean="0"/>
               <a:t>‹#›</a:t>
             </a:fld>
@@ -2127,7 +2127,7 @@
     </p:spTree>
     <p:extLst>
       <p:ext uri="{BB962C8B-B14F-4D97-AF65-F5344CB8AC3E}">
-        <p14:creationId xmlns:p14="http://schemas.microsoft.com/office/powerpoint/2010/main" val="662948693"/>
+        <p14:creationId xmlns:p14="http://schemas.microsoft.com/office/powerpoint/2010/main" val="596087884"/>
       </p:ext>
     </p:extLst>
   </p:cSld>
@@ -2159,7 +2159,7 @@
           <p:cNvPr id="2" name="Title 1">
             <a:extLst>
               <a:ext uri="{FF2B5EF4-FFF2-40B4-BE49-F238E27FC236}">
-                <a16:creationId xmlns:a16="http://schemas.microsoft.com/office/drawing/2014/main" id="{61223C24-3DD6-FF38-07B4-8B6F13370066}"/>
+                <a16:creationId xmlns:a16="http://schemas.microsoft.com/office/drawing/2014/main" id="{07B567CE-46C0-9048-4E59-DF238BE22AD5}"/>
               </a:ext>
             </a:extLst>
           </p:cNvPr>
@@ -2196,7 +2196,7 @@
           <p:cNvPr id="3" name="Content Placeholder 2">
             <a:extLst>
               <a:ext uri="{FF2B5EF4-FFF2-40B4-BE49-F238E27FC236}">
-                <a16:creationId xmlns:a16="http://schemas.microsoft.com/office/drawing/2014/main" id="{17561163-C4BA-7502-2A75-9FB17C65AA49}"/>
+                <a16:creationId xmlns:a16="http://schemas.microsoft.com/office/drawing/2014/main" id="{2127A5B4-E7ED-EFAE-1BF3-B2A13747F852}"/>
               </a:ext>
             </a:extLst>
           </p:cNvPr>
@@ -2286,7 +2286,7 @@
           <p:cNvPr id="4" name="Text Placeholder 3">
             <a:extLst>
               <a:ext uri="{FF2B5EF4-FFF2-40B4-BE49-F238E27FC236}">
-                <a16:creationId xmlns:a16="http://schemas.microsoft.com/office/drawing/2014/main" id="{5E3FEE06-744D-D72D-3027-7D09EB402EF1}"/>
+                <a16:creationId xmlns:a16="http://schemas.microsoft.com/office/drawing/2014/main" id="{158CA96C-5118-9795-E80A-C92E9934BB50}"/>
               </a:ext>
             </a:extLst>
           </p:cNvPr>
@@ -2357,7 +2357,7 @@
           <p:cNvPr id="5" name="Date Placeholder 4">
             <a:extLst>
               <a:ext uri="{FF2B5EF4-FFF2-40B4-BE49-F238E27FC236}">
-                <a16:creationId xmlns:a16="http://schemas.microsoft.com/office/drawing/2014/main" id="{59EECC70-1FC5-B9B8-341F-B5C727428C76}"/>
+                <a16:creationId xmlns:a16="http://schemas.microsoft.com/office/drawing/2014/main" id="{95825AA2-1F38-0C88-715A-CCC967A69202}"/>
               </a:ext>
             </a:extLst>
           </p:cNvPr>
@@ -2373,9 +2373,9 @@
           <a:bodyPr/>
           <a:lstStyle/>
           <a:p>
-            <a:fld id="{2D6838C7-3F3A-4EC8-A7EC-194162205776}" type="datetimeFigureOut">
+            <a:fld id="{CDE1DBC8-711B-4D7E-816B-6E1963EFEA10}" type="datetimeFigureOut">
               <a:rPr lang="en-US" smtClean="0"/>
-              <a:t>1/31/2026</a:t>
+              <a:t>5/6/2026</a:t>
             </a:fld>
             <a:endParaRPr lang="en-US"/>
           </a:p>
@@ -2386,7 +2386,7 @@
           <p:cNvPr id="6" name="Footer Placeholder 5">
             <a:extLst>
               <a:ext uri="{FF2B5EF4-FFF2-40B4-BE49-F238E27FC236}">
-                <a16:creationId xmlns:a16="http://schemas.microsoft.com/office/drawing/2014/main" id="{814DC5C1-7113-0CBB-B254-89616EF68613}"/>
+                <a16:creationId xmlns:a16="http://schemas.microsoft.com/office/drawing/2014/main" id="{5FC591FE-3147-ECCC-5858-B643130E9915}"/>
               </a:ext>
             </a:extLst>
           </p:cNvPr>
@@ -2411,7 +2411,7 @@
           <p:cNvPr id="7" name="Slide Number Placeholder 6">
             <a:extLst>
               <a:ext uri="{FF2B5EF4-FFF2-40B4-BE49-F238E27FC236}">
-                <a16:creationId xmlns:a16="http://schemas.microsoft.com/office/drawing/2014/main" id="{0D79D28C-D0E4-E1FD-C0A4-FD474CAA6B84}"/>
+                <a16:creationId xmlns:a16="http://schemas.microsoft.com/office/drawing/2014/main" id="{EE94FC89-AA85-1318-53D4-DE06E09DD27A}"/>
               </a:ext>
             </a:extLst>
           </p:cNvPr>
@@ -2427,7 +2427,7 @@
           <a:bodyPr/>
           <a:lstStyle/>
           <a:p>
-            <a:fld id="{BF2B263D-A065-4A16-816C-C56F9378FEDD}" type="slidenum">
+            <a:fld id="{2098F123-10FF-4381-B2A9-4229E307DFC7}" type="slidenum">
               <a:rPr lang="en-US" smtClean="0"/>
               <a:t>‹#›</a:t>
             </a:fld>
@@ -2438,7 +2438,7 @@
     </p:spTree>
     <p:extLst>
       <p:ext uri="{BB962C8B-B14F-4D97-AF65-F5344CB8AC3E}">
-        <p14:creationId xmlns:p14="http://schemas.microsoft.com/office/powerpoint/2010/main" val="2840659203"/>
+        <p14:creationId xmlns:p14="http://schemas.microsoft.com/office/powerpoint/2010/main" val="2172058942"/>
       </p:ext>
     </p:extLst>
   </p:cSld>
@@ -2470,7 +2470,7 @@
           <p:cNvPr id="2" name="Title 1">
             <a:extLst>
               <a:ext uri="{FF2B5EF4-FFF2-40B4-BE49-F238E27FC236}">
-                <a16:creationId xmlns:a16="http://schemas.microsoft.com/office/drawing/2014/main" id="{245E18C3-1B42-0439-58B1-85A332BD1F38}"/>
+                <a16:creationId xmlns:a16="http://schemas.microsoft.com/office/drawing/2014/main" id="{0959984B-3CD3-6DB3-0409-2133BD5033EC}"/>
               </a:ext>
             </a:extLst>
           </p:cNvPr>
@@ -2507,7 +2507,7 @@
           <p:cNvPr id="3" name="Picture Placeholder 2">
             <a:extLst>
               <a:ext uri="{FF2B5EF4-FFF2-40B4-BE49-F238E27FC236}">
-                <a16:creationId xmlns:a16="http://schemas.microsoft.com/office/drawing/2014/main" id="{59D0417E-E719-F236-FDFE-0C05C736AFEE}"/>
+                <a16:creationId xmlns:a16="http://schemas.microsoft.com/office/drawing/2014/main" id="{4297BF14-B419-EBDC-8D89-F9C1E08BB0FB}"/>
               </a:ext>
             </a:extLst>
           </p:cNvPr>
@@ -2574,7 +2574,7 @@
           <p:cNvPr id="4" name="Text Placeholder 3">
             <a:extLst>
               <a:ext uri="{FF2B5EF4-FFF2-40B4-BE49-F238E27FC236}">
-                <a16:creationId xmlns:a16="http://schemas.microsoft.com/office/drawing/2014/main" id="{3700C590-09AC-4907-96FB-91545E2A2A1E}"/>
+                <a16:creationId xmlns:a16="http://schemas.microsoft.com/office/drawing/2014/main" id="{E95409BF-B39F-9545-19CE-570C347E7D0B}"/>
               </a:ext>
             </a:extLst>
           </p:cNvPr>
@@ -2645,7 +2645,7 @@
           <p:cNvPr id="5" name="Date Placeholder 4">
             <a:extLst>
               <a:ext uri="{FF2B5EF4-FFF2-40B4-BE49-F238E27FC236}">
-                <a16:creationId xmlns:a16="http://schemas.microsoft.com/office/drawing/2014/main" id="{4BCF8234-1498-6A1A-A3DD-3858997E02ED}"/>
+                <a16:creationId xmlns:a16="http://schemas.microsoft.com/office/drawing/2014/main" id="{AAD216A7-53CB-9C57-4475-C3DEA6C1A62C}"/>
               </a:ext>
             </a:extLst>
           </p:cNvPr>
@@ -2661,9 +2661,9 @@
           <a:bodyPr/>
           <a:lstStyle/>
           <a:p>
-            <a:fld id="{2D6838C7-3F3A-4EC8-A7EC-194162205776}" type="datetimeFigureOut">
+            <a:fld id="{CDE1DBC8-711B-4D7E-816B-6E1963EFEA10}" type="datetimeFigureOut">
               <a:rPr lang="en-US" smtClean="0"/>
-              <a:t>1/31/2026</a:t>
+              <a:t>5/6/2026</a:t>
             </a:fld>
             <a:endParaRPr lang="en-US"/>
           </a:p>
@@ -2674,7 +2674,7 @@
           <p:cNvPr id="6" name="Footer Placeholder 5">
             <a:extLst>
               <a:ext uri="{FF2B5EF4-FFF2-40B4-BE49-F238E27FC236}">
-                <a16:creationId xmlns:a16="http://schemas.microsoft.com/office/drawing/2014/main" id="{4AB50C57-E4B5-10E2-2C0A-E070DC6088F6}"/>
+                <a16:creationId xmlns:a16="http://schemas.microsoft.com/office/drawing/2014/main" id="{CF0E4453-7BE2-A45C-90C5-C6D32E13BC68}"/>
               </a:ext>
             </a:extLst>
           </p:cNvPr>
@@ -2699,7 +2699,7 @@
           <p:cNvPr id="7" name="Slide Number Placeholder 6">
             <a:extLst>
               <a:ext uri="{FF2B5EF4-FFF2-40B4-BE49-F238E27FC236}">
-                <a16:creationId xmlns:a16="http://schemas.microsoft.com/office/drawing/2014/main" id="{8E09C229-CBE9-8933-F9FF-FFBE3117DD5F}"/>
+                <a16:creationId xmlns:a16="http://schemas.microsoft.com/office/drawing/2014/main" id="{F9282FD3-512F-325E-9AFE-1BADAA4D54C6}"/>
               </a:ext>
             </a:extLst>
           </p:cNvPr>
@@ -2715,7 +2715,7 @@
           <a:bodyPr/>
           <a:lstStyle/>
           <a:p>
-            <a:fld id="{BF2B263D-A065-4A16-816C-C56F9378FEDD}" type="slidenum">
+            <a:fld id="{2098F123-10FF-4381-B2A9-4229E307DFC7}" type="slidenum">
               <a:rPr lang="en-US" smtClean="0"/>
               <a:t>‹#›</a:t>
             </a:fld>
@@ -2726,7 +2726,7 @@
     </p:spTree>
     <p:extLst>
       <p:ext uri="{BB962C8B-B14F-4D97-AF65-F5344CB8AC3E}">
-        <p14:creationId xmlns:p14="http://schemas.microsoft.com/office/powerpoint/2010/main" val="458992443"/>
+        <p14:creationId xmlns:p14="http://schemas.microsoft.com/office/powerpoint/2010/main" val="2780261054"/>
       </p:ext>
     </p:extLst>
   </p:cSld>
@@ -2763,7 +2763,7 @@
           <p:cNvPr id="2" name="Title Placeholder 1">
             <a:extLst>
               <a:ext uri="{FF2B5EF4-FFF2-40B4-BE49-F238E27FC236}">
-                <a16:creationId xmlns:a16="http://schemas.microsoft.com/office/drawing/2014/main" id="{62E912AA-8004-564A-3406-A1F06EAA0492}"/>
+                <a16:creationId xmlns:a16="http://schemas.microsoft.com/office/drawing/2014/main" id="{F375CE83-A3E4-5985-8BC6-B1AED5951F48}"/>
               </a:ext>
             </a:extLst>
           </p:cNvPr>
@@ -2801,7 +2801,7 @@
           <p:cNvPr id="3" name="Text Placeholder 2">
             <a:extLst>
               <a:ext uri="{FF2B5EF4-FFF2-40B4-BE49-F238E27FC236}">
-                <a16:creationId xmlns:a16="http://schemas.microsoft.com/office/drawing/2014/main" id="{ADDF8F32-3D34-8647-7531-7E4B310F1AF7}"/>
+                <a16:creationId xmlns:a16="http://schemas.microsoft.com/office/drawing/2014/main" id="{ED7F1941-12D8-D333-A901-4DEE11D69350}"/>
               </a:ext>
             </a:extLst>
           </p:cNvPr>
@@ -2868,7 +2868,7 @@
           <p:cNvPr id="4" name="Date Placeholder 3">
             <a:extLst>
               <a:ext uri="{FF2B5EF4-FFF2-40B4-BE49-F238E27FC236}">
-                <a16:creationId xmlns:a16="http://schemas.microsoft.com/office/drawing/2014/main" id="{CDFD6EAF-9F85-6BF9-0452-EC9A87484173}"/>
+                <a16:creationId xmlns:a16="http://schemas.microsoft.com/office/drawing/2014/main" id="{634E8504-EE27-772C-2FE2-8C93AFDBEC63}"/>
               </a:ext>
             </a:extLst>
           </p:cNvPr>
@@ -2902,9 +2902,9 @@
             </a:lvl1pPr>
           </a:lstStyle>
           <a:p>
-            <a:fld id="{2D6838C7-3F3A-4EC8-A7EC-194162205776}" type="datetimeFigureOut">
+            <a:fld id="{CDE1DBC8-711B-4D7E-816B-6E1963EFEA10}" type="datetimeFigureOut">
               <a:rPr lang="en-US" smtClean="0"/>
-              <a:t>1/31/2026</a:t>
+              <a:t>5/6/2026</a:t>
             </a:fld>
             <a:endParaRPr lang="en-US"/>
           </a:p>
@@ -2915,7 +2915,7 @@
           <p:cNvPr id="5" name="Footer Placeholder 4">
             <a:extLst>
               <a:ext uri="{FF2B5EF4-FFF2-40B4-BE49-F238E27FC236}">
-                <a16:creationId xmlns:a16="http://schemas.microsoft.com/office/drawing/2014/main" id="{2093A0C3-34D6-A285-F8E7-90E83130D442}"/>
+                <a16:creationId xmlns:a16="http://schemas.microsoft.com/office/drawing/2014/main" id="{330AAA8F-5255-1EC5-1935-B7CA13436B2D}"/>
               </a:ext>
             </a:extLst>
           </p:cNvPr>
@@ -2958,7 +2958,7 @@
           <p:cNvPr id="6" name="Slide Number Placeholder 5">
             <a:extLst>
               <a:ext uri="{FF2B5EF4-FFF2-40B4-BE49-F238E27FC236}">
-                <a16:creationId xmlns:a16="http://schemas.microsoft.com/office/drawing/2014/main" id="{909F9541-062A-2EC6-DAFD-16F0F249CC3A}"/>
+                <a16:creationId xmlns:a16="http://schemas.microsoft.com/office/drawing/2014/main" id="{B0B259E8-4B28-26F4-D91B-250F91D392B8}"/>
               </a:ext>
             </a:extLst>
           </p:cNvPr>
@@ -2992,7 +2992,7 @@
             </a:lvl1pPr>
           </a:lstStyle>
           <a:p>
-            <a:fld id="{BF2B263D-A065-4A16-816C-C56F9378FEDD}" type="slidenum">
+            <a:fld id="{2098F123-10FF-4381-B2A9-4229E307DFC7}" type="slidenum">
               <a:rPr lang="en-US" smtClean="0"/>
               <a:t>‹#›</a:t>
             </a:fld>
@@ -3003,7 +3003,7 @@
     </p:spTree>
     <p:extLst>
       <p:ext uri="{BB962C8B-B14F-4D97-AF65-F5344CB8AC3E}">
-        <p14:creationId xmlns:p14="http://schemas.microsoft.com/office/powerpoint/2010/main" val="362491785"/>
+        <p14:creationId xmlns:p14="http://schemas.microsoft.com/office/powerpoint/2010/main" val="1569822876"/>
       </p:ext>
     </p:extLst>
   </p:cSld>
@@ -3326,7 +3326,7 @@
           <p:cNvPr id="2" name="Title 1">
             <a:extLst>
               <a:ext uri="{FF2B5EF4-FFF2-40B4-BE49-F238E27FC236}">
-                <a16:creationId xmlns:a16="http://schemas.microsoft.com/office/drawing/2014/main" id="{9E62067B-957E-89EC-9D47-0E1F8A8A7238}"/>
+                <a16:creationId xmlns:a16="http://schemas.microsoft.com/office/drawing/2014/main" id="{C20DC965-779B-3094-D130-96E2512992B7}"/>
               </a:ext>
             </a:extLst>
           </p:cNvPr>
@@ -3354,7 +3354,7 @@
           <p:cNvPr id="3" name="Content Placeholder 2">
             <a:extLst>
               <a:ext uri="{FF2B5EF4-FFF2-40B4-BE49-F238E27FC236}">
-                <a16:creationId xmlns:a16="http://schemas.microsoft.com/office/drawing/2014/main" id="{133B39FA-2512-BA53-D03E-7CAB1747384A}"/>
+                <a16:creationId xmlns:a16="http://schemas.microsoft.com/office/drawing/2014/main" id="{C45DF714-8C40-6DFB-3292-766F21BC3609}"/>
               </a:ext>
             </a:extLst>
           </p:cNvPr>
@@ -3379,7 +3379,7 @@
           <p:cNvPr id="4" name="Object 3">
             <a:extLst>
               <a:ext uri="{FF2B5EF4-FFF2-40B4-BE49-F238E27FC236}">
-                <a16:creationId xmlns:a16="http://schemas.microsoft.com/office/drawing/2014/main" id="{A0751C46-0B2A-A32E-D6C7-0E25AACC3200}"/>
+                <a16:creationId xmlns:a16="http://schemas.microsoft.com/office/drawing/2014/main" id="{0D0D4084-F757-C780-512A-D64A51114F8F}"/>
               </a:ext>
             </a:extLst>
           </p:cNvPr>
@@ -3389,7 +3389,7 @@
           <p:nvPr>
             <p:extLst>
               <p:ext uri="{D42A27DB-BD31-4B8C-83A1-F6EECF244321}">
-                <p14:modId xmlns:p14="http://schemas.microsoft.com/office/powerpoint/2010/main" val="3971079092"/>
+                <p14:modId xmlns:p14="http://schemas.microsoft.com/office/powerpoint/2010/main" val="2905436526"/>
               </p:ext>
             </p:extLst>
           </p:nvPr>
@@ -3440,7 +3440,7 @@
     </p:spTree>
     <p:extLst>
       <p:ext uri="{BB962C8B-B14F-4D97-AF65-F5344CB8AC3E}">
-        <p14:creationId xmlns:p14="http://schemas.microsoft.com/office/powerpoint/2010/main" val="1538482363"/>
+        <p14:creationId xmlns:p14="http://schemas.microsoft.com/office/powerpoint/2010/main" val="2969156483"/>
       </p:ext>
     </p:extLst>
   </p:cSld>

</xml_diff>

<commit_message>
Update samples and README - 2026-06-06 09:25 UTC
</commit_message>
<xml_diff>
--- a/samples/pptx_embedded_bat.pptx
+++ b/samples/pptx_embedded_bat.pptx
@@ -129,7 +129,7 @@
           <p:cNvPr id="2" name="Title 1">
             <a:extLst>
               <a:ext uri="{FF2B5EF4-FFF2-40B4-BE49-F238E27FC236}">
-                <a16:creationId xmlns:a16="http://schemas.microsoft.com/office/drawing/2014/main" id="{5FB097B0-C774-A72A-0B74-6AED6970409B}"/>
+                <a16:creationId xmlns:a16="http://schemas.microsoft.com/office/drawing/2014/main" id="{14CAC2A1-1600-F926-DA95-EBED276F05D1}"/>
               </a:ext>
             </a:extLst>
           </p:cNvPr>
@@ -166,7 +166,7 @@
           <p:cNvPr id="3" name="Subtitle 2">
             <a:extLst>
               <a:ext uri="{FF2B5EF4-FFF2-40B4-BE49-F238E27FC236}">
-                <a16:creationId xmlns:a16="http://schemas.microsoft.com/office/drawing/2014/main" id="{9FB5F4EF-CF54-1E24-1C03-9EEE11635F16}"/>
+                <a16:creationId xmlns:a16="http://schemas.microsoft.com/office/drawing/2014/main" id="{BAC39A44-6EBF-EE65-11B9-D3B63BD6DD8F}"/>
               </a:ext>
             </a:extLst>
           </p:cNvPr>
@@ -236,7 +236,7 @@
           <p:cNvPr id="4" name="Date Placeholder 3">
             <a:extLst>
               <a:ext uri="{FF2B5EF4-FFF2-40B4-BE49-F238E27FC236}">
-                <a16:creationId xmlns:a16="http://schemas.microsoft.com/office/drawing/2014/main" id="{510E8394-F1A8-B93D-FBCC-018AC4A2060A}"/>
+                <a16:creationId xmlns:a16="http://schemas.microsoft.com/office/drawing/2014/main" id="{BD76E2F2-3AF8-EF1A-CC9E-18EAEBF69556}"/>
               </a:ext>
             </a:extLst>
           </p:cNvPr>
@@ -252,9 +252,9 @@
           <a:bodyPr/>
           <a:lstStyle/>
           <a:p>
-            <a:fld id="{CDE1DBC8-711B-4D7E-816B-6E1963EFEA10}" type="datetimeFigureOut">
+            <a:fld id="{DF8941DE-3257-4F65-96BF-BB8668A1BEA1}" type="datetimeFigureOut">
               <a:rPr lang="en-US" smtClean="0"/>
-              <a:t>5/6/2026</a:t>
+              <a:t>5/23/2026</a:t>
             </a:fld>
             <a:endParaRPr lang="en-US"/>
           </a:p>
@@ -265,7 +265,7 @@
           <p:cNvPr id="5" name="Footer Placeholder 4">
             <a:extLst>
               <a:ext uri="{FF2B5EF4-FFF2-40B4-BE49-F238E27FC236}">
-                <a16:creationId xmlns:a16="http://schemas.microsoft.com/office/drawing/2014/main" id="{96163F7C-E349-63F7-DBFE-63C88FFFFA79}"/>
+                <a16:creationId xmlns:a16="http://schemas.microsoft.com/office/drawing/2014/main" id="{AECEA673-3A33-3F76-DAD2-B713BA1174A5}"/>
               </a:ext>
             </a:extLst>
           </p:cNvPr>
@@ -290,7 +290,7 @@
           <p:cNvPr id="6" name="Slide Number Placeholder 5">
             <a:extLst>
               <a:ext uri="{FF2B5EF4-FFF2-40B4-BE49-F238E27FC236}">
-                <a16:creationId xmlns:a16="http://schemas.microsoft.com/office/drawing/2014/main" id="{12167C96-8CBE-14D7-8F6B-3020A9F5AB27}"/>
+                <a16:creationId xmlns:a16="http://schemas.microsoft.com/office/drawing/2014/main" id="{FF248B09-ABBF-B45C-4AC2-5F3E519BCED1}"/>
               </a:ext>
             </a:extLst>
           </p:cNvPr>
@@ -306,7 +306,7 @@
           <a:bodyPr/>
           <a:lstStyle/>
           <a:p>
-            <a:fld id="{2098F123-10FF-4381-B2A9-4229E307DFC7}" type="slidenum">
+            <a:fld id="{8558BAA4-376B-482E-8A40-A16BD8FF12AF}" type="slidenum">
               <a:rPr lang="en-US" smtClean="0"/>
               <a:t>‹#›</a:t>
             </a:fld>
@@ -317,7 +317,7 @@
     </p:spTree>
     <p:extLst>
       <p:ext uri="{BB962C8B-B14F-4D97-AF65-F5344CB8AC3E}">
-        <p14:creationId xmlns:p14="http://schemas.microsoft.com/office/powerpoint/2010/main" val="3537101158"/>
+        <p14:creationId xmlns:p14="http://schemas.microsoft.com/office/powerpoint/2010/main" val="3722895745"/>
       </p:ext>
     </p:extLst>
   </p:cSld>
@@ -349,7 +349,7 @@
           <p:cNvPr id="2" name="Title 1">
             <a:extLst>
               <a:ext uri="{FF2B5EF4-FFF2-40B4-BE49-F238E27FC236}">
-                <a16:creationId xmlns:a16="http://schemas.microsoft.com/office/drawing/2014/main" id="{E0C31959-248F-160B-133F-842629E565CC}"/>
+                <a16:creationId xmlns:a16="http://schemas.microsoft.com/office/drawing/2014/main" id="{1F79B631-F474-FE78-01E0-3BA6B42BA161}"/>
               </a:ext>
             </a:extLst>
           </p:cNvPr>
@@ -377,7 +377,7 @@
           <p:cNvPr id="3" name="Vertical Text Placeholder 2">
             <a:extLst>
               <a:ext uri="{FF2B5EF4-FFF2-40B4-BE49-F238E27FC236}">
-                <a16:creationId xmlns:a16="http://schemas.microsoft.com/office/drawing/2014/main" id="{F7E6D14D-022D-3E78-EB48-D03A530734F5}"/>
+                <a16:creationId xmlns:a16="http://schemas.microsoft.com/office/drawing/2014/main" id="{429FD579-C6C3-6C54-C14E-90C9FE54BD97}"/>
               </a:ext>
             </a:extLst>
           </p:cNvPr>
@@ -434,7 +434,7 @@
           <p:cNvPr id="4" name="Date Placeholder 3">
             <a:extLst>
               <a:ext uri="{FF2B5EF4-FFF2-40B4-BE49-F238E27FC236}">
-                <a16:creationId xmlns:a16="http://schemas.microsoft.com/office/drawing/2014/main" id="{E5ECB923-01FF-E5B6-A6EA-F9F283F504ED}"/>
+                <a16:creationId xmlns:a16="http://schemas.microsoft.com/office/drawing/2014/main" id="{3DE53340-7DD8-6002-A2A2-08F5187ACAAA}"/>
               </a:ext>
             </a:extLst>
           </p:cNvPr>
@@ -450,9 +450,9 @@
           <a:bodyPr/>
           <a:lstStyle/>
           <a:p>
-            <a:fld id="{CDE1DBC8-711B-4D7E-816B-6E1963EFEA10}" type="datetimeFigureOut">
+            <a:fld id="{DF8941DE-3257-4F65-96BF-BB8668A1BEA1}" type="datetimeFigureOut">
               <a:rPr lang="en-US" smtClean="0"/>
-              <a:t>5/6/2026</a:t>
+              <a:t>5/23/2026</a:t>
             </a:fld>
             <a:endParaRPr lang="en-US"/>
           </a:p>
@@ -463,7 +463,7 @@
           <p:cNvPr id="5" name="Footer Placeholder 4">
             <a:extLst>
               <a:ext uri="{FF2B5EF4-FFF2-40B4-BE49-F238E27FC236}">
-                <a16:creationId xmlns:a16="http://schemas.microsoft.com/office/drawing/2014/main" id="{56299537-63BC-15B2-03A8-2BB0F1E076FE}"/>
+                <a16:creationId xmlns:a16="http://schemas.microsoft.com/office/drawing/2014/main" id="{BD5EC1C8-8A1E-E0E5-B368-5C4ACAD6EB48}"/>
               </a:ext>
             </a:extLst>
           </p:cNvPr>
@@ -488,7 +488,7 @@
           <p:cNvPr id="6" name="Slide Number Placeholder 5">
             <a:extLst>
               <a:ext uri="{FF2B5EF4-FFF2-40B4-BE49-F238E27FC236}">
-                <a16:creationId xmlns:a16="http://schemas.microsoft.com/office/drawing/2014/main" id="{C56A7033-8E65-3FB8-E249-24F26F9DFB05}"/>
+                <a16:creationId xmlns:a16="http://schemas.microsoft.com/office/drawing/2014/main" id="{0D567A85-EEC2-91CA-BFE3-85F02390F5A9}"/>
               </a:ext>
             </a:extLst>
           </p:cNvPr>
@@ -504,7 +504,7 @@
           <a:bodyPr/>
           <a:lstStyle/>
           <a:p>
-            <a:fld id="{2098F123-10FF-4381-B2A9-4229E307DFC7}" type="slidenum">
+            <a:fld id="{8558BAA4-376B-482E-8A40-A16BD8FF12AF}" type="slidenum">
               <a:rPr lang="en-US" smtClean="0"/>
               <a:t>‹#›</a:t>
             </a:fld>
@@ -515,7 +515,7 @@
     </p:spTree>
     <p:extLst>
       <p:ext uri="{BB962C8B-B14F-4D97-AF65-F5344CB8AC3E}">
-        <p14:creationId xmlns:p14="http://schemas.microsoft.com/office/powerpoint/2010/main" val="2421708651"/>
+        <p14:creationId xmlns:p14="http://schemas.microsoft.com/office/powerpoint/2010/main" val="2488484463"/>
       </p:ext>
     </p:extLst>
   </p:cSld>
@@ -547,7 +547,7 @@
           <p:cNvPr id="2" name="Vertical Title 1">
             <a:extLst>
               <a:ext uri="{FF2B5EF4-FFF2-40B4-BE49-F238E27FC236}">
-                <a16:creationId xmlns:a16="http://schemas.microsoft.com/office/drawing/2014/main" id="{14C294EF-013F-F170-1FFB-6389D23409FF}"/>
+                <a16:creationId xmlns:a16="http://schemas.microsoft.com/office/drawing/2014/main" id="{9126A21B-6AF7-9247-A9AD-9C877D951BF7}"/>
               </a:ext>
             </a:extLst>
           </p:cNvPr>
@@ -580,7 +580,7 @@
           <p:cNvPr id="3" name="Vertical Text Placeholder 2">
             <a:extLst>
               <a:ext uri="{FF2B5EF4-FFF2-40B4-BE49-F238E27FC236}">
-                <a16:creationId xmlns:a16="http://schemas.microsoft.com/office/drawing/2014/main" id="{58D45B16-1AED-933E-855A-636F54CF7D49}"/>
+                <a16:creationId xmlns:a16="http://schemas.microsoft.com/office/drawing/2014/main" id="{12744A53-0FB7-2ED5-85D4-89608034029B}"/>
               </a:ext>
             </a:extLst>
           </p:cNvPr>
@@ -642,7 +642,7 @@
           <p:cNvPr id="4" name="Date Placeholder 3">
             <a:extLst>
               <a:ext uri="{FF2B5EF4-FFF2-40B4-BE49-F238E27FC236}">
-                <a16:creationId xmlns:a16="http://schemas.microsoft.com/office/drawing/2014/main" id="{B44B4EE9-08A7-29EA-4774-DDD087FB79C0}"/>
+                <a16:creationId xmlns:a16="http://schemas.microsoft.com/office/drawing/2014/main" id="{824CAE0D-7BD4-2D32-0D8C-904952A0068D}"/>
               </a:ext>
             </a:extLst>
           </p:cNvPr>
@@ -658,9 +658,9 @@
           <a:bodyPr/>
           <a:lstStyle/>
           <a:p>
-            <a:fld id="{CDE1DBC8-711B-4D7E-816B-6E1963EFEA10}" type="datetimeFigureOut">
+            <a:fld id="{DF8941DE-3257-4F65-96BF-BB8668A1BEA1}" type="datetimeFigureOut">
               <a:rPr lang="en-US" smtClean="0"/>
-              <a:t>5/6/2026</a:t>
+              <a:t>5/23/2026</a:t>
             </a:fld>
             <a:endParaRPr lang="en-US"/>
           </a:p>
@@ -671,7 +671,7 @@
           <p:cNvPr id="5" name="Footer Placeholder 4">
             <a:extLst>
               <a:ext uri="{FF2B5EF4-FFF2-40B4-BE49-F238E27FC236}">
-                <a16:creationId xmlns:a16="http://schemas.microsoft.com/office/drawing/2014/main" id="{7DF3B117-AFF8-04FD-902F-5D0D180FF73A}"/>
+                <a16:creationId xmlns:a16="http://schemas.microsoft.com/office/drawing/2014/main" id="{C1633AFA-2DD7-FA3E-A337-810A14BB7FFC}"/>
               </a:ext>
             </a:extLst>
           </p:cNvPr>
@@ -696,7 +696,7 @@
           <p:cNvPr id="6" name="Slide Number Placeholder 5">
             <a:extLst>
               <a:ext uri="{FF2B5EF4-FFF2-40B4-BE49-F238E27FC236}">
-                <a16:creationId xmlns:a16="http://schemas.microsoft.com/office/drawing/2014/main" id="{1BD042A5-7CB6-8163-9820-2A0E82F95A0C}"/>
+                <a16:creationId xmlns:a16="http://schemas.microsoft.com/office/drawing/2014/main" id="{ABA89868-E875-0B68-B434-615DEFF9DF49}"/>
               </a:ext>
             </a:extLst>
           </p:cNvPr>
@@ -712,7 +712,7 @@
           <a:bodyPr/>
           <a:lstStyle/>
           <a:p>
-            <a:fld id="{2098F123-10FF-4381-B2A9-4229E307DFC7}" type="slidenum">
+            <a:fld id="{8558BAA4-376B-482E-8A40-A16BD8FF12AF}" type="slidenum">
               <a:rPr lang="en-US" smtClean="0"/>
               <a:t>‹#›</a:t>
             </a:fld>
@@ -723,7 +723,7 @@
     </p:spTree>
     <p:extLst>
       <p:ext uri="{BB962C8B-B14F-4D97-AF65-F5344CB8AC3E}">
-        <p14:creationId xmlns:p14="http://schemas.microsoft.com/office/powerpoint/2010/main" val="3500885383"/>
+        <p14:creationId xmlns:p14="http://schemas.microsoft.com/office/powerpoint/2010/main" val="1698372902"/>
       </p:ext>
     </p:extLst>
   </p:cSld>
@@ -755,7 +755,7 @@
           <p:cNvPr id="2" name="Title 1">
             <a:extLst>
               <a:ext uri="{FF2B5EF4-FFF2-40B4-BE49-F238E27FC236}">
-                <a16:creationId xmlns:a16="http://schemas.microsoft.com/office/drawing/2014/main" id="{54AC7F04-782D-2DC4-02DE-001C75828DCE}"/>
+                <a16:creationId xmlns:a16="http://schemas.microsoft.com/office/drawing/2014/main" id="{814F29FC-E6B2-851D-92AE-168D7EB23FCE}"/>
               </a:ext>
             </a:extLst>
           </p:cNvPr>
@@ -783,7 +783,7 @@
           <p:cNvPr id="3" name="Content Placeholder 2">
             <a:extLst>
               <a:ext uri="{FF2B5EF4-FFF2-40B4-BE49-F238E27FC236}">
-                <a16:creationId xmlns:a16="http://schemas.microsoft.com/office/drawing/2014/main" id="{92653DB5-8DEA-BA96-8A4C-298060A491F7}"/>
+                <a16:creationId xmlns:a16="http://schemas.microsoft.com/office/drawing/2014/main" id="{874F8422-7C92-CE37-A133-A63D10411CFD}"/>
               </a:ext>
             </a:extLst>
           </p:cNvPr>
@@ -840,7 +840,7 @@
           <p:cNvPr id="4" name="Date Placeholder 3">
             <a:extLst>
               <a:ext uri="{FF2B5EF4-FFF2-40B4-BE49-F238E27FC236}">
-                <a16:creationId xmlns:a16="http://schemas.microsoft.com/office/drawing/2014/main" id="{415B212A-7761-2436-D6C6-FBE241F36779}"/>
+                <a16:creationId xmlns:a16="http://schemas.microsoft.com/office/drawing/2014/main" id="{63F07F69-620E-3492-34F9-B050441C21AF}"/>
               </a:ext>
             </a:extLst>
           </p:cNvPr>
@@ -856,9 +856,9 @@
           <a:bodyPr/>
           <a:lstStyle/>
           <a:p>
-            <a:fld id="{CDE1DBC8-711B-4D7E-816B-6E1963EFEA10}" type="datetimeFigureOut">
+            <a:fld id="{DF8941DE-3257-4F65-96BF-BB8668A1BEA1}" type="datetimeFigureOut">
               <a:rPr lang="en-US" smtClean="0"/>
-              <a:t>5/6/2026</a:t>
+              <a:t>5/23/2026</a:t>
             </a:fld>
             <a:endParaRPr lang="en-US"/>
           </a:p>
@@ -869,7 +869,7 @@
           <p:cNvPr id="5" name="Footer Placeholder 4">
             <a:extLst>
               <a:ext uri="{FF2B5EF4-FFF2-40B4-BE49-F238E27FC236}">
-                <a16:creationId xmlns:a16="http://schemas.microsoft.com/office/drawing/2014/main" id="{F85D3F36-113C-EA55-AD95-601B173702F3}"/>
+                <a16:creationId xmlns:a16="http://schemas.microsoft.com/office/drawing/2014/main" id="{CB600F91-2110-D215-E2B9-22B420759DBE}"/>
               </a:ext>
             </a:extLst>
           </p:cNvPr>
@@ -894,7 +894,7 @@
           <p:cNvPr id="6" name="Slide Number Placeholder 5">
             <a:extLst>
               <a:ext uri="{FF2B5EF4-FFF2-40B4-BE49-F238E27FC236}">
-                <a16:creationId xmlns:a16="http://schemas.microsoft.com/office/drawing/2014/main" id="{20923392-6B71-089F-9F6E-281A4AF30096}"/>
+                <a16:creationId xmlns:a16="http://schemas.microsoft.com/office/drawing/2014/main" id="{812CDA3D-335E-15A6-B8B5-6CC7D8332A90}"/>
               </a:ext>
             </a:extLst>
           </p:cNvPr>
@@ -910,7 +910,7 @@
           <a:bodyPr/>
           <a:lstStyle/>
           <a:p>
-            <a:fld id="{2098F123-10FF-4381-B2A9-4229E307DFC7}" type="slidenum">
+            <a:fld id="{8558BAA4-376B-482E-8A40-A16BD8FF12AF}" type="slidenum">
               <a:rPr lang="en-US" smtClean="0"/>
               <a:t>‹#›</a:t>
             </a:fld>
@@ -921,7 +921,7 @@
     </p:spTree>
     <p:extLst>
       <p:ext uri="{BB962C8B-B14F-4D97-AF65-F5344CB8AC3E}">
-        <p14:creationId xmlns:p14="http://schemas.microsoft.com/office/powerpoint/2010/main" val="1038363221"/>
+        <p14:creationId xmlns:p14="http://schemas.microsoft.com/office/powerpoint/2010/main" val="3233236565"/>
       </p:ext>
     </p:extLst>
   </p:cSld>
@@ -953,7 +953,7 @@
           <p:cNvPr id="2" name="Title 1">
             <a:extLst>
               <a:ext uri="{FF2B5EF4-FFF2-40B4-BE49-F238E27FC236}">
-                <a16:creationId xmlns:a16="http://schemas.microsoft.com/office/drawing/2014/main" id="{2E358849-2A90-098F-14E1-0E76B5E916A9}"/>
+                <a16:creationId xmlns:a16="http://schemas.microsoft.com/office/drawing/2014/main" id="{83043E5D-5CAC-E13A-6084-E9C13A324457}"/>
               </a:ext>
             </a:extLst>
           </p:cNvPr>
@@ -990,7 +990,7 @@
           <p:cNvPr id="3" name="Text Placeholder 2">
             <a:extLst>
               <a:ext uri="{FF2B5EF4-FFF2-40B4-BE49-F238E27FC236}">
-                <a16:creationId xmlns:a16="http://schemas.microsoft.com/office/drawing/2014/main" id="{9FEBE48D-07E4-1045-9440-7A0E649F510D}"/>
+                <a16:creationId xmlns:a16="http://schemas.microsoft.com/office/drawing/2014/main" id="{4B65EFA4-52B5-8E7A-4272-FB7E6123D444}"/>
               </a:ext>
             </a:extLst>
           </p:cNvPr>
@@ -1015,7 +1015,7 @@
               <a:defRPr sz="2400">
                 <a:solidFill>
                   <a:schemeClr val="tx1">
-                    <a:tint val="82000"/>
+                    <a:tint val="75000"/>
                   </a:schemeClr>
                 </a:solidFill>
               </a:defRPr>
@@ -1025,7 +1025,7 @@
               <a:defRPr sz="2000">
                 <a:solidFill>
                   <a:schemeClr val="tx1">
-                    <a:tint val="82000"/>
+                    <a:tint val="75000"/>
                   </a:schemeClr>
                 </a:solidFill>
               </a:defRPr>
@@ -1035,7 +1035,7 @@
               <a:defRPr sz="1800">
                 <a:solidFill>
                   <a:schemeClr val="tx1">
-                    <a:tint val="82000"/>
+                    <a:tint val="75000"/>
                   </a:schemeClr>
                 </a:solidFill>
               </a:defRPr>
@@ -1045,7 +1045,7 @@
               <a:defRPr sz="1600">
                 <a:solidFill>
                   <a:schemeClr val="tx1">
-                    <a:tint val="82000"/>
+                    <a:tint val="75000"/>
                   </a:schemeClr>
                 </a:solidFill>
               </a:defRPr>
@@ -1055,7 +1055,7 @@
               <a:defRPr sz="1600">
                 <a:solidFill>
                   <a:schemeClr val="tx1">
-                    <a:tint val="82000"/>
+                    <a:tint val="75000"/>
                   </a:schemeClr>
                 </a:solidFill>
               </a:defRPr>
@@ -1065,7 +1065,7 @@
               <a:defRPr sz="1600">
                 <a:solidFill>
                   <a:schemeClr val="tx1">
-                    <a:tint val="82000"/>
+                    <a:tint val="75000"/>
                   </a:schemeClr>
                 </a:solidFill>
               </a:defRPr>
@@ -1075,7 +1075,7 @@
               <a:defRPr sz="1600">
                 <a:solidFill>
                   <a:schemeClr val="tx1">
-                    <a:tint val="82000"/>
+                    <a:tint val="75000"/>
                   </a:schemeClr>
                 </a:solidFill>
               </a:defRPr>
@@ -1085,7 +1085,7 @@
               <a:defRPr sz="1600">
                 <a:solidFill>
                   <a:schemeClr val="tx1">
-                    <a:tint val="82000"/>
+                    <a:tint val="75000"/>
                   </a:schemeClr>
                 </a:solidFill>
               </a:defRPr>
@@ -1095,7 +1095,7 @@
               <a:defRPr sz="1600">
                 <a:solidFill>
                   <a:schemeClr val="tx1">
-                    <a:tint val="82000"/>
+                    <a:tint val="75000"/>
                   </a:schemeClr>
                 </a:solidFill>
               </a:defRPr>
@@ -1115,7 +1115,7 @@
           <p:cNvPr id="4" name="Date Placeholder 3">
             <a:extLst>
               <a:ext uri="{FF2B5EF4-FFF2-40B4-BE49-F238E27FC236}">
-                <a16:creationId xmlns:a16="http://schemas.microsoft.com/office/drawing/2014/main" id="{1A07C54B-C6F2-7ABE-494A-129AABDDE7D0}"/>
+                <a16:creationId xmlns:a16="http://schemas.microsoft.com/office/drawing/2014/main" id="{D94C8F35-BC80-2328-4DD4-4AB2E51B2E1B}"/>
               </a:ext>
             </a:extLst>
           </p:cNvPr>
@@ -1131,9 +1131,9 @@
           <a:bodyPr/>
           <a:lstStyle/>
           <a:p>
-            <a:fld id="{CDE1DBC8-711B-4D7E-816B-6E1963EFEA10}" type="datetimeFigureOut">
+            <a:fld id="{DF8941DE-3257-4F65-96BF-BB8668A1BEA1}" type="datetimeFigureOut">
               <a:rPr lang="en-US" smtClean="0"/>
-              <a:t>5/6/2026</a:t>
+              <a:t>5/23/2026</a:t>
             </a:fld>
             <a:endParaRPr lang="en-US"/>
           </a:p>
@@ -1144,7 +1144,7 @@
           <p:cNvPr id="5" name="Footer Placeholder 4">
             <a:extLst>
               <a:ext uri="{FF2B5EF4-FFF2-40B4-BE49-F238E27FC236}">
-                <a16:creationId xmlns:a16="http://schemas.microsoft.com/office/drawing/2014/main" id="{496C478C-CE67-3441-7094-D206E94810EC}"/>
+                <a16:creationId xmlns:a16="http://schemas.microsoft.com/office/drawing/2014/main" id="{EBF77992-BA5B-CCEC-8E9F-AB8C811EC560}"/>
               </a:ext>
             </a:extLst>
           </p:cNvPr>
@@ -1169,7 +1169,7 @@
           <p:cNvPr id="6" name="Slide Number Placeholder 5">
             <a:extLst>
               <a:ext uri="{FF2B5EF4-FFF2-40B4-BE49-F238E27FC236}">
-                <a16:creationId xmlns:a16="http://schemas.microsoft.com/office/drawing/2014/main" id="{B7447A2F-9FC7-18E5-C84A-3063F389AC74}"/>
+                <a16:creationId xmlns:a16="http://schemas.microsoft.com/office/drawing/2014/main" id="{DD766D92-6F4B-F8DE-FCBF-20DDFBBF4E88}"/>
               </a:ext>
             </a:extLst>
           </p:cNvPr>
@@ -1185,7 +1185,7 @@
           <a:bodyPr/>
           <a:lstStyle/>
           <a:p>
-            <a:fld id="{2098F123-10FF-4381-B2A9-4229E307DFC7}" type="slidenum">
+            <a:fld id="{8558BAA4-376B-482E-8A40-A16BD8FF12AF}" type="slidenum">
               <a:rPr lang="en-US" smtClean="0"/>
               <a:t>‹#›</a:t>
             </a:fld>
@@ -1196,7 +1196,7 @@
     </p:spTree>
     <p:extLst>
       <p:ext uri="{BB962C8B-B14F-4D97-AF65-F5344CB8AC3E}">
-        <p14:creationId xmlns:p14="http://schemas.microsoft.com/office/powerpoint/2010/main" val="3741346164"/>
+        <p14:creationId xmlns:p14="http://schemas.microsoft.com/office/powerpoint/2010/main" val="980002271"/>
       </p:ext>
     </p:extLst>
   </p:cSld>
@@ -1228,7 +1228,7 @@
           <p:cNvPr id="2" name="Title 1">
             <a:extLst>
               <a:ext uri="{FF2B5EF4-FFF2-40B4-BE49-F238E27FC236}">
-                <a16:creationId xmlns:a16="http://schemas.microsoft.com/office/drawing/2014/main" id="{6C7D479F-0076-1A15-1B61-57B0A8DD8E63}"/>
+                <a16:creationId xmlns:a16="http://schemas.microsoft.com/office/drawing/2014/main" id="{F77849D5-F421-9B8E-B9C8-8D2E63376CE4}"/>
               </a:ext>
             </a:extLst>
           </p:cNvPr>
@@ -1256,7 +1256,7 @@
           <p:cNvPr id="3" name="Content Placeholder 2">
             <a:extLst>
               <a:ext uri="{FF2B5EF4-FFF2-40B4-BE49-F238E27FC236}">
-                <a16:creationId xmlns:a16="http://schemas.microsoft.com/office/drawing/2014/main" id="{A6B56F65-EBAC-014E-6243-9F1D60E3E0F9}"/>
+                <a16:creationId xmlns:a16="http://schemas.microsoft.com/office/drawing/2014/main" id="{293BAE44-8CFC-D931-0A39-E7AC3964D6C4}"/>
               </a:ext>
             </a:extLst>
           </p:cNvPr>
@@ -1318,7 +1318,7 @@
           <p:cNvPr id="4" name="Content Placeholder 3">
             <a:extLst>
               <a:ext uri="{FF2B5EF4-FFF2-40B4-BE49-F238E27FC236}">
-                <a16:creationId xmlns:a16="http://schemas.microsoft.com/office/drawing/2014/main" id="{9CEDF937-376A-68E5-082B-7A59B2116EBB}"/>
+                <a16:creationId xmlns:a16="http://schemas.microsoft.com/office/drawing/2014/main" id="{92195EC2-C4A9-DB4A-E903-90EA265FD555}"/>
               </a:ext>
             </a:extLst>
           </p:cNvPr>
@@ -1380,7 +1380,7 @@
           <p:cNvPr id="5" name="Date Placeholder 4">
             <a:extLst>
               <a:ext uri="{FF2B5EF4-FFF2-40B4-BE49-F238E27FC236}">
-                <a16:creationId xmlns:a16="http://schemas.microsoft.com/office/drawing/2014/main" id="{B3329157-E8C2-3401-00A3-39917A08FDA1}"/>
+                <a16:creationId xmlns:a16="http://schemas.microsoft.com/office/drawing/2014/main" id="{06518152-4268-8716-5BA9-2DE5B264D8CA}"/>
               </a:ext>
             </a:extLst>
           </p:cNvPr>
@@ -1396,9 +1396,9 @@
           <a:bodyPr/>
           <a:lstStyle/>
           <a:p>
-            <a:fld id="{CDE1DBC8-711B-4D7E-816B-6E1963EFEA10}" type="datetimeFigureOut">
+            <a:fld id="{DF8941DE-3257-4F65-96BF-BB8668A1BEA1}" type="datetimeFigureOut">
               <a:rPr lang="en-US" smtClean="0"/>
-              <a:t>5/6/2026</a:t>
+              <a:t>5/23/2026</a:t>
             </a:fld>
             <a:endParaRPr lang="en-US"/>
           </a:p>
@@ -1409,7 +1409,7 @@
           <p:cNvPr id="6" name="Footer Placeholder 5">
             <a:extLst>
               <a:ext uri="{FF2B5EF4-FFF2-40B4-BE49-F238E27FC236}">
-                <a16:creationId xmlns:a16="http://schemas.microsoft.com/office/drawing/2014/main" id="{1362711B-5DF7-B899-A3AD-6DF18F691A21}"/>
+                <a16:creationId xmlns:a16="http://schemas.microsoft.com/office/drawing/2014/main" id="{DE46DAC6-98F2-D064-D05C-FE2CFF8C567A}"/>
               </a:ext>
             </a:extLst>
           </p:cNvPr>
@@ -1434,7 +1434,7 @@
           <p:cNvPr id="7" name="Slide Number Placeholder 6">
             <a:extLst>
               <a:ext uri="{FF2B5EF4-FFF2-40B4-BE49-F238E27FC236}">
-                <a16:creationId xmlns:a16="http://schemas.microsoft.com/office/drawing/2014/main" id="{889C0909-DC1F-7C9C-D272-F5374AC8774C}"/>
+                <a16:creationId xmlns:a16="http://schemas.microsoft.com/office/drawing/2014/main" id="{FE2F8003-AAFB-9442-478A-86ADA59763A6}"/>
               </a:ext>
             </a:extLst>
           </p:cNvPr>
@@ -1450,7 +1450,7 @@
           <a:bodyPr/>
           <a:lstStyle/>
           <a:p>
-            <a:fld id="{2098F123-10FF-4381-B2A9-4229E307DFC7}" type="slidenum">
+            <a:fld id="{8558BAA4-376B-482E-8A40-A16BD8FF12AF}" type="slidenum">
               <a:rPr lang="en-US" smtClean="0"/>
               <a:t>‹#›</a:t>
             </a:fld>
@@ -1461,7 +1461,7 @@
     </p:spTree>
     <p:extLst>
       <p:ext uri="{BB962C8B-B14F-4D97-AF65-F5344CB8AC3E}">
-        <p14:creationId xmlns:p14="http://schemas.microsoft.com/office/powerpoint/2010/main" val="4000992804"/>
+        <p14:creationId xmlns:p14="http://schemas.microsoft.com/office/powerpoint/2010/main" val="3975007756"/>
       </p:ext>
     </p:extLst>
   </p:cSld>
@@ -1493,7 +1493,7 @@
           <p:cNvPr id="2" name="Title 1">
             <a:extLst>
               <a:ext uri="{FF2B5EF4-FFF2-40B4-BE49-F238E27FC236}">
-                <a16:creationId xmlns:a16="http://schemas.microsoft.com/office/drawing/2014/main" id="{943F8E25-D343-5463-2C73-2D79139DD0A2}"/>
+                <a16:creationId xmlns:a16="http://schemas.microsoft.com/office/drawing/2014/main" id="{3D64418D-35ED-90A9-C866-AAF8ECF7B922}"/>
               </a:ext>
             </a:extLst>
           </p:cNvPr>
@@ -1526,7 +1526,7 @@
           <p:cNvPr id="3" name="Text Placeholder 2">
             <a:extLst>
               <a:ext uri="{FF2B5EF4-FFF2-40B4-BE49-F238E27FC236}">
-                <a16:creationId xmlns:a16="http://schemas.microsoft.com/office/drawing/2014/main" id="{119D070F-AC7D-A307-9BA7-C0E537DB0390}"/>
+                <a16:creationId xmlns:a16="http://schemas.microsoft.com/office/drawing/2014/main" id="{8E120278-23FB-B997-79E3-6FA5A9274664}"/>
               </a:ext>
             </a:extLst>
           </p:cNvPr>
@@ -1597,7 +1597,7 @@
           <p:cNvPr id="4" name="Content Placeholder 3">
             <a:extLst>
               <a:ext uri="{FF2B5EF4-FFF2-40B4-BE49-F238E27FC236}">
-                <a16:creationId xmlns:a16="http://schemas.microsoft.com/office/drawing/2014/main" id="{FFD3C363-BA3D-EF52-83CA-CE24452285D6}"/>
+                <a16:creationId xmlns:a16="http://schemas.microsoft.com/office/drawing/2014/main" id="{3536F349-28CD-F93B-D992-D93EE1A1DC5D}"/>
               </a:ext>
             </a:extLst>
           </p:cNvPr>
@@ -1659,7 +1659,7 @@
           <p:cNvPr id="5" name="Text Placeholder 4">
             <a:extLst>
               <a:ext uri="{FF2B5EF4-FFF2-40B4-BE49-F238E27FC236}">
-                <a16:creationId xmlns:a16="http://schemas.microsoft.com/office/drawing/2014/main" id="{F6B74B6D-56A4-99EB-4F16-8056CE010ADE}"/>
+                <a16:creationId xmlns:a16="http://schemas.microsoft.com/office/drawing/2014/main" id="{39588C42-3981-DC3D-C792-06650B9F0FAE}"/>
               </a:ext>
             </a:extLst>
           </p:cNvPr>
@@ -1730,7 +1730,7 @@
           <p:cNvPr id="6" name="Content Placeholder 5">
             <a:extLst>
               <a:ext uri="{FF2B5EF4-FFF2-40B4-BE49-F238E27FC236}">
-                <a16:creationId xmlns:a16="http://schemas.microsoft.com/office/drawing/2014/main" id="{5F6B5AD6-81EB-A30C-5537-43053A989FAB}"/>
+                <a16:creationId xmlns:a16="http://schemas.microsoft.com/office/drawing/2014/main" id="{485BF816-8489-BA00-F18D-0B434DCCF863}"/>
               </a:ext>
             </a:extLst>
           </p:cNvPr>
@@ -1792,7 +1792,7 @@
           <p:cNvPr id="7" name="Date Placeholder 6">
             <a:extLst>
               <a:ext uri="{FF2B5EF4-FFF2-40B4-BE49-F238E27FC236}">
-                <a16:creationId xmlns:a16="http://schemas.microsoft.com/office/drawing/2014/main" id="{FCA92201-A627-F622-459B-CCD8D98DDB88}"/>
+                <a16:creationId xmlns:a16="http://schemas.microsoft.com/office/drawing/2014/main" id="{A4227A91-13D0-784D-5AB9-EDAD6C9CF0E0}"/>
               </a:ext>
             </a:extLst>
           </p:cNvPr>
@@ -1808,9 +1808,9 @@
           <a:bodyPr/>
           <a:lstStyle/>
           <a:p>
-            <a:fld id="{CDE1DBC8-711B-4D7E-816B-6E1963EFEA10}" type="datetimeFigureOut">
+            <a:fld id="{DF8941DE-3257-4F65-96BF-BB8668A1BEA1}" type="datetimeFigureOut">
               <a:rPr lang="en-US" smtClean="0"/>
-              <a:t>5/6/2026</a:t>
+              <a:t>5/23/2026</a:t>
             </a:fld>
             <a:endParaRPr lang="en-US"/>
           </a:p>
@@ -1821,7 +1821,7 @@
           <p:cNvPr id="8" name="Footer Placeholder 7">
             <a:extLst>
               <a:ext uri="{FF2B5EF4-FFF2-40B4-BE49-F238E27FC236}">
-                <a16:creationId xmlns:a16="http://schemas.microsoft.com/office/drawing/2014/main" id="{52E4BEB4-5FDF-81EE-E6EF-50827B57D065}"/>
+                <a16:creationId xmlns:a16="http://schemas.microsoft.com/office/drawing/2014/main" id="{2525F1D8-1E6B-B833-147A-1D27809D4784}"/>
               </a:ext>
             </a:extLst>
           </p:cNvPr>
@@ -1846,7 +1846,7 @@
           <p:cNvPr id="9" name="Slide Number Placeholder 8">
             <a:extLst>
               <a:ext uri="{FF2B5EF4-FFF2-40B4-BE49-F238E27FC236}">
-                <a16:creationId xmlns:a16="http://schemas.microsoft.com/office/drawing/2014/main" id="{4C59A272-2F28-B6BE-BC70-7128D7FB8963}"/>
+                <a16:creationId xmlns:a16="http://schemas.microsoft.com/office/drawing/2014/main" id="{66E7AEE6-E14D-5318-0C68-FB885C207CEC}"/>
               </a:ext>
             </a:extLst>
           </p:cNvPr>
@@ -1862,7 +1862,7 @@
           <a:bodyPr/>
           <a:lstStyle/>
           <a:p>
-            <a:fld id="{2098F123-10FF-4381-B2A9-4229E307DFC7}" type="slidenum">
+            <a:fld id="{8558BAA4-376B-482E-8A40-A16BD8FF12AF}" type="slidenum">
               <a:rPr lang="en-US" smtClean="0"/>
               <a:t>‹#›</a:t>
             </a:fld>
@@ -1873,7 +1873,7 @@
     </p:spTree>
     <p:extLst>
       <p:ext uri="{BB962C8B-B14F-4D97-AF65-F5344CB8AC3E}">
-        <p14:creationId xmlns:p14="http://schemas.microsoft.com/office/powerpoint/2010/main" val="3412846155"/>
+        <p14:creationId xmlns:p14="http://schemas.microsoft.com/office/powerpoint/2010/main" val="1946343068"/>
       </p:ext>
     </p:extLst>
   </p:cSld>
@@ -1905,7 +1905,7 @@
           <p:cNvPr id="2" name="Title 1">
             <a:extLst>
               <a:ext uri="{FF2B5EF4-FFF2-40B4-BE49-F238E27FC236}">
-                <a16:creationId xmlns:a16="http://schemas.microsoft.com/office/drawing/2014/main" id="{D34FF40F-DB35-4D1B-5C8F-B8B6ECBBAB4C}"/>
+                <a16:creationId xmlns:a16="http://schemas.microsoft.com/office/drawing/2014/main" id="{C7ACAAA0-417E-938C-7D95-58BBC5DB98F9}"/>
               </a:ext>
             </a:extLst>
           </p:cNvPr>
@@ -1933,7 +1933,7 @@
           <p:cNvPr id="3" name="Date Placeholder 2">
             <a:extLst>
               <a:ext uri="{FF2B5EF4-FFF2-40B4-BE49-F238E27FC236}">
-                <a16:creationId xmlns:a16="http://schemas.microsoft.com/office/drawing/2014/main" id="{933512F8-1758-D7B3-41F6-538694FEF824}"/>
+                <a16:creationId xmlns:a16="http://schemas.microsoft.com/office/drawing/2014/main" id="{87AA3BFB-832E-6068-2AC8-ED824A8A8EDA}"/>
               </a:ext>
             </a:extLst>
           </p:cNvPr>
@@ -1949,9 +1949,9 @@
           <a:bodyPr/>
           <a:lstStyle/>
           <a:p>
-            <a:fld id="{CDE1DBC8-711B-4D7E-816B-6E1963EFEA10}" type="datetimeFigureOut">
+            <a:fld id="{DF8941DE-3257-4F65-96BF-BB8668A1BEA1}" type="datetimeFigureOut">
               <a:rPr lang="en-US" smtClean="0"/>
-              <a:t>5/6/2026</a:t>
+              <a:t>5/23/2026</a:t>
             </a:fld>
             <a:endParaRPr lang="en-US"/>
           </a:p>
@@ -1962,7 +1962,7 @@
           <p:cNvPr id="4" name="Footer Placeholder 3">
             <a:extLst>
               <a:ext uri="{FF2B5EF4-FFF2-40B4-BE49-F238E27FC236}">
-                <a16:creationId xmlns:a16="http://schemas.microsoft.com/office/drawing/2014/main" id="{B45C1E37-0D3C-8320-598F-539AD8D4DB14}"/>
+                <a16:creationId xmlns:a16="http://schemas.microsoft.com/office/drawing/2014/main" id="{0AD6584C-BAD5-5C14-90D9-25C9763C1E73}"/>
               </a:ext>
             </a:extLst>
           </p:cNvPr>
@@ -1987,7 +1987,7 @@
           <p:cNvPr id="5" name="Slide Number Placeholder 4">
             <a:extLst>
               <a:ext uri="{FF2B5EF4-FFF2-40B4-BE49-F238E27FC236}">
-                <a16:creationId xmlns:a16="http://schemas.microsoft.com/office/drawing/2014/main" id="{E2E0FAB2-4A23-6EA8-5113-464C88036C0F}"/>
+                <a16:creationId xmlns:a16="http://schemas.microsoft.com/office/drawing/2014/main" id="{6C45EB7E-4791-E112-9591-9A76DF5CAB17}"/>
               </a:ext>
             </a:extLst>
           </p:cNvPr>
@@ -2003,7 +2003,7 @@
           <a:bodyPr/>
           <a:lstStyle/>
           <a:p>
-            <a:fld id="{2098F123-10FF-4381-B2A9-4229E307DFC7}" type="slidenum">
+            <a:fld id="{8558BAA4-376B-482E-8A40-A16BD8FF12AF}" type="slidenum">
               <a:rPr lang="en-US" smtClean="0"/>
               <a:t>‹#›</a:t>
             </a:fld>
@@ -2014,7 +2014,7 @@
     </p:spTree>
     <p:extLst>
       <p:ext uri="{BB962C8B-B14F-4D97-AF65-F5344CB8AC3E}">
-        <p14:creationId xmlns:p14="http://schemas.microsoft.com/office/powerpoint/2010/main" val="3300053734"/>
+        <p14:creationId xmlns:p14="http://schemas.microsoft.com/office/powerpoint/2010/main" val="1688403415"/>
       </p:ext>
     </p:extLst>
   </p:cSld>
@@ -2046,7 +2046,7 @@
           <p:cNvPr id="2" name="Date Placeholder 1">
             <a:extLst>
               <a:ext uri="{FF2B5EF4-FFF2-40B4-BE49-F238E27FC236}">
-                <a16:creationId xmlns:a16="http://schemas.microsoft.com/office/drawing/2014/main" id="{4E6843A7-3704-C183-93FA-105BE379C5E5}"/>
+                <a16:creationId xmlns:a16="http://schemas.microsoft.com/office/drawing/2014/main" id="{5D616C4E-EE2F-A69B-7697-540065A5A57F}"/>
               </a:ext>
             </a:extLst>
           </p:cNvPr>
@@ -2062,9 +2062,9 @@
           <a:bodyPr/>
           <a:lstStyle/>
           <a:p>
-            <a:fld id="{CDE1DBC8-711B-4D7E-816B-6E1963EFEA10}" type="datetimeFigureOut">
+            <a:fld id="{DF8941DE-3257-4F65-96BF-BB8668A1BEA1}" type="datetimeFigureOut">
               <a:rPr lang="en-US" smtClean="0"/>
-              <a:t>5/6/2026</a:t>
+              <a:t>5/23/2026</a:t>
             </a:fld>
             <a:endParaRPr lang="en-US"/>
           </a:p>
@@ -2075,7 +2075,7 @@
           <p:cNvPr id="3" name="Footer Placeholder 2">
             <a:extLst>
               <a:ext uri="{FF2B5EF4-FFF2-40B4-BE49-F238E27FC236}">
-                <a16:creationId xmlns:a16="http://schemas.microsoft.com/office/drawing/2014/main" id="{6C261032-B7C3-B816-C0F6-5674F0A5E515}"/>
+                <a16:creationId xmlns:a16="http://schemas.microsoft.com/office/drawing/2014/main" id="{D0FD7309-CB20-6134-E959-46D7AC619624}"/>
               </a:ext>
             </a:extLst>
           </p:cNvPr>
@@ -2100,7 +2100,7 @@
           <p:cNvPr id="4" name="Slide Number Placeholder 3">
             <a:extLst>
               <a:ext uri="{FF2B5EF4-FFF2-40B4-BE49-F238E27FC236}">
-                <a16:creationId xmlns:a16="http://schemas.microsoft.com/office/drawing/2014/main" id="{A1B79A3C-9B34-59F8-5A8B-8F3D17CC8889}"/>
+                <a16:creationId xmlns:a16="http://schemas.microsoft.com/office/drawing/2014/main" id="{ADD63A71-2872-CC61-A895-EED0F7D6D662}"/>
               </a:ext>
             </a:extLst>
           </p:cNvPr>
@@ -2116,7 +2116,7 @@
           <a:bodyPr/>
           <a:lstStyle/>
           <a:p>
-            <a:fld id="{2098F123-10FF-4381-B2A9-4229E307DFC7}" type="slidenum">
+            <a:fld id="{8558BAA4-376B-482E-8A40-A16BD8FF12AF}" type="slidenum">
               <a:rPr lang="en-US" smtClean="0"/>
               <a:t>‹#›</a:t>
             </a:fld>
@@ -2127,7 +2127,7 @@
     </p:spTree>
     <p:extLst>
       <p:ext uri="{BB962C8B-B14F-4D97-AF65-F5344CB8AC3E}">
-        <p14:creationId xmlns:p14="http://schemas.microsoft.com/office/powerpoint/2010/main" val="596087884"/>
+        <p14:creationId xmlns:p14="http://schemas.microsoft.com/office/powerpoint/2010/main" val="311557738"/>
       </p:ext>
     </p:extLst>
   </p:cSld>
@@ -2159,7 +2159,7 @@
           <p:cNvPr id="2" name="Title 1">
             <a:extLst>
               <a:ext uri="{FF2B5EF4-FFF2-40B4-BE49-F238E27FC236}">
-                <a16:creationId xmlns:a16="http://schemas.microsoft.com/office/drawing/2014/main" id="{07B567CE-46C0-9048-4E59-DF238BE22AD5}"/>
+                <a16:creationId xmlns:a16="http://schemas.microsoft.com/office/drawing/2014/main" id="{DCF0640B-E79E-D7A3-12A1-EFF26E91E64A}"/>
               </a:ext>
             </a:extLst>
           </p:cNvPr>
@@ -2196,7 +2196,7 @@
           <p:cNvPr id="3" name="Content Placeholder 2">
             <a:extLst>
               <a:ext uri="{FF2B5EF4-FFF2-40B4-BE49-F238E27FC236}">
-                <a16:creationId xmlns:a16="http://schemas.microsoft.com/office/drawing/2014/main" id="{2127A5B4-E7ED-EFAE-1BF3-B2A13747F852}"/>
+                <a16:creationId xmlns:a16="http://schemas.microsoft.com/office/drawing/2014/main" id="{EDC40DAD-E55A-6C11-E9ED-20596571EC26}"/>
               </a:ext>
             </a:extLst>
           </p:cNvPr>
@@ -2286,7 +2286,7 @@
           <p:cNvPr id="4" name="Text Placeholder 3">
             <a:extLst>
               <a:ext uri="{FF2B5EF4-FFF2-40B4-BE49-F238E27FC236}">
-                <a16:creationId xmlns:a16="http://schemas.microsoft.com/office/drawing/2014/main" id="{158CA96C-5118-9795-E80A-C92E9934BB50}"/>
+                <a16:creationId xmlns:a16="http://schemas.microsoft.com/office/drawing/2014/main" id="{3D1F5D9E-9864-64C6-E297-60512F0AFAD1}"/>
               </a:ext>
             </a:extLst>
           </p:cNvPr>
@@ -2357,7 +2357,7 @@
           <p:cNvPr id="5" name="Date Placeholder 4">
             <a:extLst>
               <a:ext uri="{FF2B5EF4-FFF2-40B4-BE49-F238E27FC236}">
-                <a16:creationId xmlns:a16="http://schemas.microsoft.com/office/drawing/2014/main" id="{95825AA2-1F38-0C88-715A-CCC967A69202}"/>
+                <a16:creationId xmlns:a16="http://schemas.microsoft.com/office/drawing/2014/main" id="{4FBED633-DE35-5C9D-446D-776CA685BF77}"/>
               </a:ext>
             </a:extLst>
           </p:cNvPr>
@@ -2373,9 +2373,9 @@
           <a:bodyPr/>
           <a:lstStyle/>
           <a:p>
-            <a:fld id="{CDE1DBC8-711B-4D7E-816B-6E1963EFEA10}" type="datetimeFigureOut">
+            <a:fld id="{DF8941DE-3257-4F65-96BF-BB8668A1BEA1}" type="datetimeFigureOut">
               <a:rPr lang="en-US" smtClean="0"/>
-              <a:t>5/6/2026</a:t>
+              <a:t>5/23/2026</a:t>
             </a:fld>
             <a:endParaRPr lang="en-US"/>
           </a:p>
@@ -2386,7 +2386,7 @@
           <p:cNvPr id="6" name="Footer Placeholder 5">
             <a:extLst>
               <a:ext uri="{FF2B5EF4-FFF2-40B4-BE49-F238E27FC236}">
-                <a16:creationId xmlns:a16="http://schemas.microsoft.com/office/drawing/2014/main" id="{5FC591FE-3147-ECCC-5858-B643130E9915}"/>
+                <a16:creationId xmlns:a16="http://schemas.microsoft.com/office/drawing/2014/main" id="{3E4B6F82-053D-4E0B-68D6-6219FC87975E}"/>
               </a:ext>
             </a:extLst>
           </p:cNvPr>
@@ -2411,7 +2411,7 @@
           <p:cNvPr id="7" name="Slide Number Placeholder 6">
             <a:extLst>
               <a:ext uri="{FF2B5EF4-FFF2-40B4-BE49-F238E27FC236}">
-                <a16:creationId xmlns:a16="http://schemas.microsoft.com/office/drawing/2014/main" id="{EE94FC89-AA85-1318-53D4-DE06E09DD27A}"/>
+                <a16:creationId xmlns:a16="http://schemas.microsoft.com/office/drawing/2014/main" id="{8B23AC72-095E-D165-38CE-CE67D70BE43B}"/>
               </a:ext>
             </a:extLst>
           </p:cNvPr>
@@ -2427,7 +2427,7 @@
           <a:bodyPr/>
           <a:lstStyle/>
           <a:p>
-            <a:fld id="{2098F123-10FF-4381-B2A9-4229E307DFC7}" type="slidenum">
+            <a:fld id="{8558BAA4-376B-482E-8A40-A16BD8FF12AF}" type="slidenum">
               <a:rPr lang="en-US" smtClean="0"/>
               <a:t>‹#›</a:t>
             </a:fld>
@@ -2438,7 +2438,7 @@
     </p:spTree>
     <p:extLst>
       <p:ext uri="{BB962C8B-B14F-4D97-AF65-F5344CB8AC3E}">
-        <p14:creationId xmlns:p14="http://schemas.microsoft.com/office/powerpoint/2010/main" val="2172058942"/>
+        <p14:creationId xmlns:p14="http://schemas.microsoft.com/office/powerpoint/2010/main" val="3499424749"/>
       </p:ext>
     </p:extLst>
   </p:cSld>
@@ -2470,7 +2470,7 @@
           <p:cNvPr id="2" name="Title 1">
             <a:extLst>
               <a:ext uri="{FF2B5EF4-FFF2-40B4-BE49-F238E27FC236}">
-                <a16:creationId xmlns:a16="http://schemas.microsoft.com/office/drawing/2014/main" id="{0959984B-3CD3-6DB3-0409-2133BD5033EC}"/>
+                <a16:creationId xmlns:a16="http://schemas.microsoft.com/office/drawing/2014/main" id="{8BA7003C-6655-9129-8D82-D1A75A1B5EFE}"/>
               </a:ext>
             </a:extLst>
           </p:cNvPr>
@@ -2507,7 +2507,7 @@
           <p:cNvPr id="3" name="Picture Placeholder 2">
             <a:extLst>
               <a:ext uri="{FF2B5EF4-FFF2-40B4-BE49-F238E27FC236}">
-                <a16:creationId xmlns:a16="http://schemas.microsoft.com/office/drawing/2014/main" id="{4297BF14-B419-EBDC-8D89-F9C1E08BB0FB}"/>
+                <a16:creationId xmlns:a16="http://schemas.microsoft.com/office/drawing/2014/main" id="{F5DA883A-5AA4-0EED-C4FE-CF5D4ED5013E}"/>
               </a:ext>
             </a:extLst>
           </p:cNvPr>
@@ -2574,7 +2574,7 @@
           <p:cNvPr id="4" name="Text Placeholder 3">
             <a:extLst>
               <a:ext uri="{FF2B5EF4-FFF2-40B4-BE49-F238E27FC236}">
-                <a16:creationId xmlns:a16="http://schemas.microsoft.com/office/drawing/2014/main" id="{E95409BF-B39F-9545-19CE-570C347E7D0B}"/>
+                <a16:creationId xmlns:a16="http://schemas.microsoft.com/office/drawing/2014/main" id="{A4674419-7AE8-8A56-B172-094627B6EA07}"/>
               </a:ext>
             </a:extLst>
           </p:cNvPr>
@@ -2645,7 +2645,7 @@
           <p:cNvPr id="5" name="Date Placeholder 4">
             <a:extLst>
               <a:ext uri="{FF2B5EF4-FFF2-40B4-BE49-F238E27FC236}">
-                <a16:creationId xmlns:a16="http://schemas.microsoft.com/office/drawing/2014/main" id="{AAD216A7-53CB-9C57-4475-C3DEA6C1A62C}"/>
+                <a16:creationId xmlns:a16="http://schemas.microsoft.com/office/drawing/2014/main" id="{549C07F8-713A-A91B-10E3-232214A9765E}"/>
               </a:ext>
             </a:extLst>
           </p:cNvPr>
@@ -2661,9 +2661,9 @@
           <a:bodyPr/>
           <a:lstStyle/>
           <a:p>
-            <a:fld id="{CDE1DBC8-711B-4D7E-816B-6E1963EFEA10}" type="datetimeFigureOut">
+            <a:fld id="{DF8941DE-3257-4F65-96BF-BB8668A1BEA1}" type="datetimeFigureOut">
               <a:rPr lang="en-US" smtClean="0"/>
-              <a:t>5/6/2026</a:t>
+              <a:t>5/23/2026</a:t>
             </a:fld>
             <a:endParaRPr lang="en-US"/>
           </a:p>
@@ -2674,7 +2674,7 @@
           <p:cNvPr id="6" name="Footer Placeholder 5">
             <a:extLst>
               <a:ext uri="{FF2B5EF4-FFF2-40B4-BE49-F238E27FC236}">
-                <a16:creationId xmlns:a16="http://schemas.microsoft.com/office/drawing/2014/main" id="{CF0E4453-7BE2-A45C-90C5-C6D32E13BC68}"/>
+                <a16:creationId xmlns:a16="http://schemas.microsoft.com/office/drawing/2014/main" id="{7C91D655-FD2D-66EB-8697-14C67244379C}"/>
               </a:ext>
             </a:extLst>
           </p:cNvPr>
@@ -2699,7 +2699,7 @@
           <p:cNvPr id="7" name="Slide Number Placeholder 6">
             <a:extLst>
               <a:ext uri="{FF2B5EF4-FFF2-40B4-BE49-F238E27FC236}">
-                <a16:creationId xmlns:a16="http://schemas.microsoft.com/office/drawing/2014/main" id="{F9282FD3-512F-325E-9AFE-1BADAA4D54C6}"/>
+                <a16:creationId xmlns:a16="http://schemas.microsoft.com/office/drawing/2014/main" id="{36D3A642-9231-1765-6131-E9B9B6C5400C}"/>
               </a:ext>
             </a:extLst>
           </p:cNvPr>
@@ -2715,7 +2715,7 @@
           <a:bodyPr/>
           <a:lstStyle/>
           <a:p>
-            <a:fld id="{2098F123-10FF-4381-B2A9-4229E307DFC7}" type="slidenum">
+            <a:fld id="{8558BAA4-376B-482E-8A40-A16BD8FF12AF}" type="slidenum">
               <a:rPr lang="en-US" smtClean="0"/>
               <a:t>‹#›</a:t>
             </a:fld>
@@ -2726,7 +2726,7 @@
     </p:spTree>
     <p:extLst>
       <p:ext uri="{BB962C8B-B14F-4D97-AF65-F5344CB8AC3E}">
-        <p14:creationId xmlns:p14="http://schemas.microsoft.com/office/powerpoint/2010/main" val="2780261054"/>
+        <p14:creationId xmlns:p14="http://schemas.microsoft.com/office/powerpoint/2010/main" val="3475606430"/>
       </p:ext>
     </p:extLst>
   </p:cSld>
@@ -2763,7 +2763,7 @@
           <p:cNvPr id="2" name="Title Placeholder 1">
             <a:extLst>
               <a:ext uri="{FF2B5EF4-FFF2-40B4-BE49-F238E27FC236}">
-                <a16:creationId xmlns:a16="http://schemas.microsoft.com/office/drawing/2014/main" id="{F375CE83-A3E4-5985-8BC6-B1AED5951F48}"/>
+                <a16:creationId xmlns:a16="http://schemas.microsoft.com/office/drawing/2014/main" id="{01212EF6-C65C-6667-23FB-A7788F846E1F}"/>
               </a:ext>
             </a:extLst>
           </p:cNvPr>
@@ -2801,7 +2801,7 @@
           <p:cNvPr id="3" name="Text Placeholder 2">
             <a:extLst>
               <a:ext uri="{FF2B5EF4-FFF2-40B4-BE49-F238E27FC236}">
-                <a16:creationId xmlns:a16="http://schemas.microsoft.com/office/drawing/2014/main" id="{ED7F1941-12D8-D333-A901-4DEE11D69350}"/>
+                <a16:creationId xmlns:a16="http://schemas.microsoft.com/office/drawing/2014/main" id="{7C67791C-A60D-4757-BF37-E593A51DB92F}"/>
               </a:ext>
             </a:extLst>
           </p:cNvPr>
@@ -2868,7 +2868,7 @@
           <p:cNvPr id="4" name="Date Placeholder 3">
             <a:extLst>
               <a:ext uri="{FF2B5EF4-FFF2-40B4-BE49-F238E27FC236}">
-                <a16:creationId xmlns:a16="http://schemas.microsoft.com/office/drawing/2014/main" id="{634E8504-EE27-772C-2FE2-8C93AFDBEC63}"/>
+                <a16:creationId xmlns:a16="http://schemas.microsoft.com/office/drawing/2014/main" id="{1219FBF4-D2E3-0B14-9A44-33C5BF33F412}"/>
               </a:ext>
             </a:extLst>
           </p:cNvPr>
@@ -2895,16 +2895,16 @@
               <a:defRPr sz="1200">
                 <a:solidFill>
                   <a:schemeClr val="tx1">
-                    <a:tint val="82000"/>
+                    <a:tint val="75000"/>
                   </a:schemeClr>
                 </a:solidFill>
               </a:defRPr>
             </a:lvl1pPr>
           </a:lstStyle>
           <a:p>
-            <a:fld id="{CDE1DBC8-711B-4D7E-816B-6E1963EFEA10}" type="datetimeFigureOut">
+            <a:fld id="{DF8941DE-3257-4F65-96BF-BB8668A1BEA1}" type="datetimeFigureOut">
               <a:rPr lang="en-US" smtClean="0"/>
-              <a:t>5/6/2026</a:t>
+              <a:t>5/23/2026</a:t>
             </a:fld>
             <a:endParaRPr lang="en-US"/>
           </a:p>
@@ -2915,7 +2915,7 @@
           <p:cNvPr id="5" name="Footer Placeholder 4">
             <a:extLst>
               <a:ext uri="{FF2B5EF4-FFF2-40B4-BE49-F238E27FC236}">
-                <a16:creationId xmlns:a16="http://schemas.microsoft.com/office/drawing/2014/main" id="{330AAA8F-5255-1EC5-1935-B7CA13436B2D}"/>
+                <a16:creationId xmlns:a16="http://schemas.microsoft.com/office/drawing/2014/main" id="{325DD882-20B7-B76E-A3A7-318CEBD69616}"/>
               </a:ext>
             </a:extLst>
           </p:cNvPr>
@@ -2942,7 +2942,7 @@
               <a:defRPr sz="1200">
                 <a:solidFill>
                   <a:schemeClr val="tx1">
-                    <a:tint val="82000"/>
+                    <a:tint val="75000"/>
                   </a:schemeClr>
                 </a:solidFill>
               </a:defRPr>
@@ -2958,7 +2958,7 @@
           <p:cNvPr id="6" name="Slide Number Placeholder 5">
             <a:extLst>
               <a:ext uri="{FF2B5EF4-FFF2-40B4-BE49-F238E27FC236}">
-                <a16:creationId xmlns:a16="http://schemas.microsoft.com/office/drawing/2014/main" id="{B0B259E8-4B28-26F4-D91B-250F91D392B8}"/>
+                <a16:creationId xmlns:a16="http://schemas.microsoft.com/office/drawing/2014/main" id="{3FC83FA1-C184-48D3-489D-5EFC6D908F9E}"/>
               </a:ext>
             </a:extLst>
           </p:cNvPr>
@@ -2985,14 +2985,14 @@
               <a:defRPr sz="1200">
                 <a:solidFill>
                   <a:schemeClr val="tx1">
-                    <a:tint val="82000"/>
+                    <a:tint val="75000"/>
                   </a:schemeClr>
                 </a:solidFill>
               </a:defRPr>
             </a:lvl1pPr>
           </a:lstStyle>
           <a:p>
-            <a:fld id="{2098F123-10FF-4381-B2A9-4229E307DFC7}" type="slidenum">
+            <a:fld id="{8558BAA4-376B-482E-8A40-A16BD8FF12AF}" type="slidenum">
               <a:rPr lang="en-US" smtClean="0"/>
               <a:t>‹#›</a:t>
             </a:fld>
@@ -3003,7 +3003,7 @@
     </p:spTree>
     <p:extLst>
       <p:ext uri="{BB962C8B-B14F-4D97-AF65-F5344CB8AC3E}">
-        <p14:creationId xmlns:p14="http://schemas.microsoft.com/office/powerpoint/2010/main" val="1569822876"/>
+        <p14:creationId xmlns:p14="http://schemas.microsoft.com/office/powerpoint/2010/main" val="1490953980"/>
       </p:ext>
     </p:extLst>
   </p:cSld>
@@ -3326,7 +3326,7 @@
           <p:cNvPr id="2" name="Title 1">
             <a:extLst>
               <a:ext uri="{FF2B5EF4-FFF2-40B4-BE49-F238E27FC236}">
-                <a16:creationId xmlns:a16="http://schemas.microsoft.com/office/drawing/2014/main" id="{C20DC965-779B-3094-D130-96E2512992B7}"/>
+                <a16:creationId xmlns:a16="http://schemas.microsoft.com/office/drawing/2014/main" id="{D1B9C88B-B5FF-7C42-3DB2-F369647FF801}"/>
               </a:ext>
             </a:extLst>
           </p:cNvPr>
@@ -3354,7 +3354,7 @@
           <p:cNvPr id="3" name="Content Placeholder 2">
             <a:extLst>
               <a:ext uri="{FF2B5EF4-FFF2-40B4-BE49-F238E27FC236}">
-                <a16:creationId xmlns:a16="http://schemas.microsoft.com/office/drawing/2014/main" id="{C45DF714-8C40-6DFB-3292-766F21BC3609}"/>
+                <a16:creationId xmlns:a16="http://schemas.microsoft.com/office/drawing/2014/main" id="{38999E89-FAD3-847E-E12F-4AE2BEF27A21}"/>
               </a:ext>
             </a:extLst>
           </p:cNvPr>
@@ -3379,7 +3379,7 @@
           <p:cNvPr id="4" name="Object 3">
             <a:extLst>
               <a:ext uri="{FF2B5EF4-FFF2-40B4-BE49-F238E27FC236}">
-                <a16:creationId xmlns:a16="http://schemas.microsoft.com/office/drawing/2014/main" id="{0D0D4084-F757-C780-512A-D64A51114F8F}"/>
+                <a16:creationId xmlns:a16="http://schemas.microsoft.com/office/drawing/2014/main" id="{F06488DF-7C95-D7AF-E21D-BF41BA1D68D4}"/>
               </a:ext>
             </a:extLst>
           </p:cNvPr>
@@ -3389,7 +3389,7 @@
           <p:nvPr>
             <p:extLst>
               <p:ext uri="{D42A27DB-BD31-4B8C-83A1-F6EECF244321}">
-                <p14:modId xmlns:p14="http://schemas.microsoft.com/office/powerpoint/2010/main" val="2905436526"/>
+                <p14:modId xmlns:p14="http://schemas.microsoft.com/office/powerpoint/2010/main" val="125184086"/>
               </p:ext>
             </p:extLst>
           </p:nvPr>
@@ -3440,7 +3440,7 @@
     </p:spTree>
     <p:extLst>
       <p:ext uri="{BB962C8B-B14F-4D97-AF65-F5344CB8AC3E}">
-        <p14:creationId xmlns:p14="http://schemas.microsoft.com/office/powerpoint/2010/main" val="2969156483"/>
+        <p14:creationId xmlns:p14="http://schemas.microsoft.com/office/powerpoint/2010/main" val="2331871804"/>
       </p:ext>
     </p:extLst>
   </p:cSld>
@@ -3461,39 +3461,39 @@
         <a:sysClr val="window" lastClr="FFFFFF"/>
       </a:lt1>
       <a:dk2>
-        <a:srgbClr val="0E2841"/>
+        <a:srgbClr val="44546A"/>
       </a:dk2>
       <a:lt2>
-        <a:srgbClr val="E8E8E8"/>
+        <a:srgbClr val="E7E6E6"/>
       </a:lt2>
       <a:accent1>
-        <a:srgbClr val="156082"/>
+        <a:srgbClr val="4472C4"/>
       </a:accent1>
       <a:accent2>
-        <a:srgbClr val="E97132"/>
+        <a:srgbClr val="ED7D31"/>
       </a:accent2>
       <a:accent3>
-        <a:srgbClr val="196B24"/>
+        <a:srgbClr val="A5A5A5"/>
       </a:accent3>
       <a:accent4>
-        <a:srgbClr val="0F9ED5"/>
+        <a:srgbClr val="FFC000"/>
       </a:accent4>
       <a:accent5>
-        <a:srgbClr val="A02B93"/>
+        <a:srgbClr val="5B9BD5"/>
       </a:accent5>
       <a:accent6>
-        <a:srgbClr val="4EA72E"/>
+        <a:srgbClr val="70AD47"/>
       </a:accent6>
       <a:hlink>
-        <a:srgbClr val="467886"/>
+        <a:srgbClr val="0563C1"/>
       </a:hlink>
       <a:folHlink>
-        <a:srgbClr val="96607D"/>
+        <a:srgbClr val="954F72"/>
       </a:folHlink>
     </a:clrScheme>
     <a:fontScheme name="Office">
       <a:majorFont>
-        <a:latin typeface="Aptos Display" panose="02110004020202020204"/>
+        <a:latin typeface="Calibri Light" panose="020F0302020204030204"/>
         <a:ea typeface=""/>
         <a:cs typeface=""/>
         <a:font script="Jpan" typeface="游ゴシック Light"/>
@@ -3545,7 +3545,7 @@
         <a:font script="Tfng" typeface="Ebrima"/>
       </a:majorFont>
       <a:minorFont>
-        <a:latin typeface="Aptos" panose="02110004020202020204"/>
+        <a:latin typeface="Calibri" panose="020F0502020204030204"/>
         <a:ea typeface=""/>
         <a:cs typeface=""/>
         <a:font script="Jpan" typeface="游ゴシック"/>
@@ -3656,6 +3656,13 @@
         </a:gradFill>
       </a:fillStyleLst>
       <a:lnStyleLst>
+        <a:ln w="6350" cap="flat" cmpd="sng" algn="ctr">
+          <a:solidFill>
+            <a:schemeClr val="phClr"/>
+          </a:solidFill>
+          <a:prstDash val="solid"/>
+          <a:miter lim="800000"/>
+        </a:ln>
         <a:ln w="12700" cap="flat" cmpd="sng" algn="ctr">
           <a:solidFill>
             <a:schemeClr val="phClr"/>
@@ -3664,13 +3671,6 @@
           <a:miter lim="800000"/>
         </a:ln>
         <a:ln w="19050" cap="flat" cmpd="sng" algn="ctr">
-          <a:solidFill>
-            <a:schemeClr val="phClr"/>
-          </a:solidFill>
-          <a:prstDash val="solid"/>
-          <a:miter lim="800000"/>
-        </a:ln>
-        <a:ln w="25400" cap="flat" cmpd="sng" algn="ctr">
           <a:solidFill>
             <a:schemeClr val="phClr"/>
           </a:solidFill>
@@ -3735,31 +3735,11 @@
       </a:bgFillStyleLst>
     </a:fmtScheme>
   </a:themeElements>
-  <a:objectDefaults>
-    <a:lnDef>
-      <a:spPr/>
-      <a:bodyPr/>
-      <a:lstStyle/>
-      <a:style>
-        <a:lnRef idx="2">
-          <a:schemeClr val="accent1"/>
-        </a:lnRef>
-        <a:fillRef idx="0">
-          <a:schemeClr val="accent1"/>
-        </a:fillRef>
-        <a:effectRef idx="1">
-          <a:schemeClr val="accent1"/>
-        </a:effectRef>
-        <a:fontRef idx="minor">
-          <a:schemeClr val="tx1"/>
-        </a:fontRef>
-      </a:style>
-    </a:lnDef>
-  </a:objectDefaults>
+  <a:objectDefaults/>
   <a:extraClrSchemeLst/>
   <a:extLst>
     <a:ext uri="{05A4C25C-085E-4340-85A3-A5531E510DB2}">
-      <thm15:themeFamily xmlns:thm15="http://schemas.microsoft.com/office/thememl/2012/main" name="Office Theme" id="{2E142A2C-CD16-42D6-873A-C26D2A0506FA}" vid="{1BDDFF52-6CD6-40A5-AB3C-68EB2F1E4D0A}"/>
+      <thm15:themeFamily xmlns:thm15="http://schemas.microsoft.com/office/thememl/2012/main" name="Office Theme" id="{62F939B6-93AF-4DB8-9C6B-D6C7DFDC589F}" vid="{4A3C46E8-61CC-4603-A589-7422A47A8E4A}"/>
     </a:ext>
   </a:extLst>
 </a:theme>

</xml_diff>